<commit_message>
Rework deck v3: DSX OS domain-based reference tier with SKT-led development on top
- Slide 6 redesigned as two tiers: DSX OS reference base grouped by
  Compute/Network/Storage/Facility domains, SKT development layer above,
  connected via standard interfaces (OTel/Redfish/MQTT/MCP)
- Replace "joint development" subject with "SKT development (leveraging DSX OS)"
  across slides 2, 5, 7, 9, 11, 12, backup C, and speaker notes
- Recount slide 7 matrix: SKT 13 (9 own + 4 DSX-assisted), DSX-provided 7

Co-Authored-By: Claude Fable 5 <noreply@anthropic.com>
Claude-Session: https://claude.ai/code/session_01NF2WLQMvns3fBzWioYNUFC
</commit_message>
<xml_diff>
--- a/_workspace/NVIDIA_DSX_OS_E2E_Observability_논의.pptx
+++ b/_workspace/NVIDIA_DSX_OS_E2E_Observability_논의.pptx
@@ -1244,7 +1244,7 @@
               <a:rPr lang="en-US" dirty="0"/>
               <a:t>[Executive Summary 0:30~2:30 — 절대 스킵 불가]
 "핵심은 이 한 장에 다 있습니다. 저희 SKT는 이미 GPU 클러스터를 운영하며 Observability 솔루션을 직접 개발해 온 경험이 있습니다. 여기에 NVIDIA가 새로 공개한 DSX OS의 운영 프레임워크를 결합하면, Vera Rubin 기반 AI Factory의 Compute·Network·Storage·Facility를 관통하는 End-to-end 통합 관제를 가장 빠르고 확실하게 확보할 수 있습니다. 개발 목표는 명확합니다. 업계 최고 수준으로 평가받는 CoreWeave와 유사한 수준의 모니터링·분석 환경을 확보하는 것입니다.
-이를 위해 오늘 세 가지 확정을 요청드립니다. 첫째, 아키텍처 방향 — DSX OS를 골격으로 한 E2E 레이어드 구조. 둘째, 개발·연동 범위 — DSX OS가 제공하는 것, 저희가 개발하는 것, 공동으로 개발하는 것의 경계. 셋째, 수집 전략과 단계화입니다. 각각 뒤에서 근거를 말씀드리고, 마지막 장에서 다시 이 세 가지로 돌아오겠습니다."
+이를 위해 오늘 세 가지 확정을 요청드립니다. 첫째, 아키텍처 방향 — DSX OS를 골격으로 한 E2E 레이어드 구조. 둘째, 개발·연동 범위 — DSX OS가 기반으로 제공하는 것과 저희가 그 위에 개발하는 것의 경계. 셋째, 수집 전략과 단계화입니다. 각각 뒤에서 근거를 말씀드리고, 마지막 장에서 다시 이 세 가지로 돌아오겠습니다."
 강조: 결정 카드 3개를 하나씩 짚는다. "CoreWeave 유사 수준" 또렷하게.
 전환: "먼저 '저희가 이걸 할 수 있는 조직인가'부터 보여드리겠습니다."</a:t>
             </a:r>
@@ -1613,10 +1613,10 @@
             <a:r>
               <a:rPr lang="en-US" dirty="0"/>
               <a:t>[2-2 목표 아키텍처 D1 7:30~10:00 — 절정 1, 절대 스킵 불가]
-"이것이 제안드리는 전체 구조입니다. 다섯 개 층인데, 아래에서 위로 보시면 됩니다.
-비유로 먼저 — 종합병원의 환자 모니터링과 같습니다. 맨 아래 1층이 환자 몸에 붙는 각종 센서, 2층이 그 신호를 한데 모으는 배선, 3층이 진료 기록 보관, 4층이 의사의 진단, 맨 위 5층이 간호사 스테이션의 통합 모니터와 응급 호출 시스템입니다. 지금까지는 장비마다 따로 봤다면, 이제 병원 전체를 한 화면에서 보자는 것입니다.
-(1층) 수집층에는 GPU를 보는 DCGM, 서버가 죽어도 동작하는 BMC 수집기, DPU 오프로드, 네트워크의 UFM, 전력·냉각의 DSX Exchange까지 — 네 도메인이 전부 들어옵니다. (2~3층) OpenTelemetry 표준 파이프라인으로 모아 시계열 저장소에 쌓고, (4층) DSX OS의 Health Automation과 저희가 개발하는 이상 탐지·장애 예측·상관분석이 돌아가며, (5층) 통합 대시보드와 대화형 운영 AI 에이전트로 올라갑니다.
-색을 봐 주십시오. 초록은 DSX OS 기본 제공, 파랑은 SKT 개발, 주황은 공동 개발입니다. 골격은 DSX OS가 제공하고, 저희는 잘하는 분석과 시각화에 집중한다 — 이것이 오늘 첫 번째 결정 D1입니다."
+"이것이 제안드리는 전체 구조입니다. 두 개 층입니다 — 아래는 DSX OS가 제공하는 도메인별 기반, 위는 그것을 활용해 저희가 개발하는 E2E 관제 레이어입니다.
+비유로 먼저 — 종합병원과 같습니다. 아래층(초록)은 병원이 갖춘 검사 장비들 — 도메인별 센서와 신호가 이미 나옵니다. 위층(파랑)은 저희가 만드는 통합 진단실 — 모든 신호를 한데 모아 진단하고 예측하는 곳입니다. 장비는 DSX OS가 제공하고, 진단 체계는 저희가 만듭니다.
+(하단) DSX OS Reference 기반을 네 도메인으로 정리했습니다 — Compute의 DCGM과 Health Automation, Network의 UFM·Spectrum, Storage의 STX·DPU 오프로드, Facility의 DSX Exchange까지, 도메인별 텔레메트리와 운영 기능이 이미 제공됩니다. (중간) 연결은 전부 표준 인터페이스 — OpenTelemetry·Redfish·MQTT·MCP입니다. (상단) 그 위에 저희 SKT가 수집 파이프라인부터 저장·분석·통합 대시보드·운영 AI 에이전트까지 E2E 관제 레이어를 개발합니다.
+색을 봐 주십시오. 초록은 DSX OS가 도메인별로 기본 제공하는 기반 기술, 파랑은 SKT가 자체 개발하는 영역, 주황은 DSX OS의 데이터와 컴포넌트를 활용해 SKT가 개발하는 영역입니다. 기반은 DSX OS가 제공하고, 그 위의 개발은 전부 SKT가 주도한다 — 이것이 오늘 첫 번째 결정 D1입니다. 공동 개발이 아니라, DSX OS의 도움을 받아 SKT가 개발하는 구조입니다."
 강조: 우상단 D1 배지 짚기. DSX OS 6모듈 캡션은 질문 시만 활용.
 전환: "구조를 채택한다면, 다음 질문은 '그 안에서 누가 어디까지 만드나'입니다."</a:t>
             </a:r>
@@ -1707,7 +1707,7 @@
             <a:r>
               <a:rPr lang="en-US" dirty="0"/>
               <a:t>[2-3 범위·역할 분담 D2 10:00~12:30 — 첫 결정 요청, 절대 스킵 불가]
-"표가 복잡해 보이지만 읽는 법은 간단합니다. 색만 봐 주십시오. 수집과 자동 복구는 대부분 초록 — DSX OS가 제공합니다. 분석과 시각화는 대부분 파랑 — 저희가 개발합니다. 그 접점이 주황 — 공동 개발입니다. 주체가 지정된 20개 영역 중 SKT 단독 개발은 9개입니다. 개발 총량의 절반 이상을 DSX OS와 공동 영역이 흡수하는 구조라, 전면 자체 개발 대비 공수와 리스크가 크게 줄어듭니다.
+"표가 복잡해 보이지만 읽는 법은 간단합니다. 색만 봐 주십시오. 수집과 자동 복구는 대부분 초록 — DSX OS가 기반으로 제공합니다. 분석과 시각화는 파랑과 주황 — 전부 저희가 개발하며, 주황은 DSX OS 데이터를 활용하는 부분입니다. 주황은 DSX OS의 데이터·컴포넌트를 활용해 저희가 개발하는 영역입니다. 주체가 지정된 20개 영역 중 SKT가 개발하는 것이 13개(이 중 4개는 DSX OS 활용), DSX OS가 기본 제공하는 기반이 7개입니다. 개발 주체는 저희지만 기반을 DSX OS가 제공하므로, 전면 자체 구축 대비 공수와 리스크가 크게 줄어듭니다.
 다만 별표 네 곳은 오늘 여러분의 의견이 필요합니다. 첫째, 기존 분석 모델을 어디까지 재활용할지. 둘째, 자동 복구가 잡을 자동 재시작하는 것을 어디까지 허용할지. 셋째, 스토리지 랙 복구 권한을 어디까지 NVIDIA 쪽 모듈에 줄지. 넷째, 전력·냉각처럼 안전 규제가 걸리는 IT/OT 경계의 책임 소재입니다."
 ★청중 참여(30초, 필수): "이 네 가지 중 지금 바로 방향을 주실 수 있는 항목이 있으십니까? 특히 자동 복구 허용 수준은 운영 철학의 문제라 임원분들 판단이 중요합니다." 의견이 나오면 12페이지에서 확정 문구로 정리. 5분 이상 길어지면 Discussion으로 커트.
 전환: "예상 질문 — 'Mission Control이 이미 있는데 우리가 뭘 만드나, 종속되는 것 아니냐.' 그 답이 다음 장입니다."</a:t>
@@ -6529,7 +6529,7 @@
                 <a:ea typeface="Malgun Gothic" pitchFamily="34" charset="-122"/>
                 <a:cs typeface="Malgun Gothic" pitchFamily="34" charset="-120"/>
               </a:rPr>
-              <a:t>패브릭-잡 상관분석 (잡 성능 저하 ↔ 네트워크 혼잡 매핑) — 공동</a:t>
+              <a:t>패브릭-잡 상관분석 (잡 성능 저하 ↔ 네트워크 혼잡 매핑) — SKT, UFM 데이터 활용</a:t>
             </a:r>
             <a:endParaRPr lang="en-US" sz="950" dirty="0"/>
           </a:p>
@@ -7649,7 +7649,7 @@
                 <a:ea typeface="Malgun Gothic" pitchFamily="34" charset="-122"/>
                 <a:cs typeface="Malgun Gothic" pitchFamily="34" charset="-120"/>
               </a:rPr>
-              <a:t>Facility-aware 상관분석 (SKT 기존 경험 접목 [확인: SKT]), 전력-워크로드 연계 — 공동</a:t>
+              <a:t>Facility-aware 상관분석 (SKT 기존 경험 접목 [확인: SKT]), 전력-워크로드 연계 — SKT, Exchange 데이터 활용</a:t>
             </a:r>
             <a:endParaRPr lang="en-US" sz="950" dirty="0"/>
           </a:p>
@@ -7806,7 +7806,7 @@
         <p:spPr>
           <a:xfrm>
             <a:off x="698500" y="6070600"/>
-            <a:ext cx="1498600" cy="203200"/>
+            <a:ext cx="1651000" cy="203200"/>
           </a:xfrm>
           <a:prstGeom prst="rect">
             <a:avLst/>
@@ -7847,7 +7847,7 @@
         </p:nvSpPr>
         <p:spPr>
           <a:xfrm>
-            <a:off x="2286000" y="6096000"/>
+            <a:off x="2514600" y="6096000"/>
             <a:ext cx="139700" cy="139700"/>
           </a:xfrm>
           <a:prstGeom prst="rect">
@@ -7872,8 +7872,8 @@
         </p:nvSpPr>
         <p:spPr>
           <a:xfrm>
-            <a:off x="2476500" y="6070600"/>
-            <a:ext cx="1498600" cy="203200"/>
+            <a:off x="2705100" y="6070600"/>
+            <a:ext cx="1143000" cy="203200"/>
           </a:xfrm>
           <a:prstGeom prst="rect">
             <a:avLst/>
@@ -7914,7 +7914,7 @@
         </p:nvSpPr>
         <p:spPr>
           <a:xfrm>
-            <a:off x="4064000" y="6096000"/>
+            <a:off x="4013200" y="6096000"/>
             <a:ext cx="139700" cy="139700"/>
           </a:xfrm>
           <a:prstGeom prst="rect">
@@ -7939,8 +7939,8 @@
         </p:nvSpPr>
         <p:spPr>
           <a:xfrm>
-            <a:off x="4254500" y="6070600"/>
-            <a:ext cx="1498600" cy="203200"/>
+            <a:off x="4203700" y="6070600"/>
+            <a:ext cx="2159000" cy="203200"/>
           </a:xfrm>
           <a:prstGeom prst="rect">
             <a:avLst/>
@@ -7967,7 +7967,7 @@
                 <a:ea typeface="Malgun Gothic" pitchFamily="34" charset="-122"/>
                 <a:cs typeface="Malgun Gothic" pitchFamily="34" charset="-120"/>
               </a:rPr>
-              <a:t>공동 개발</a:t>
+              <a:t>SKT 개발 (DSX OS 활용)</a:t>
             </a:r>
             <a:endParaRPr lang="en-US" sz="1050" dirty="0"/>
           </a:p>
@@ -8526,7 +8526,7 @@
                 <a:ea typeface="Malgun Gothic" pitchFamily="34" charset="-122"/>
                 <a:cs typeface="Malgun Gothic" pitchFamily="34" charset="-120"/>
               </a:rPr>
-              <a:t>범위 매트릭스 기준 역할 분담 확정 — ★4개 항목 포함</a:t>
+              <a:t>범위 매트릭스 기준 SKT 개발 범위 확정 — ★4개 항목 포함</a:t>
             </a:r>
             <a:endParaRPr lang="en-US" sz="1050" dirty="0"/>
           </a:p>
@@ -13367,7 +13367,7 @@
                           <a:ea typeface="Malgun Gothic" pitchFamily="34" charset="-122"/>
                           <a:cs typeface="Malgun Gothic" pitchFamily="34" charset="-120"/>
                         </a:rPr>
-                        <a:t>DSX OS MCP 서버 카탈로그 기반 Agentic 운영 (Phase 3, 공동)</a:t>
+                        <a:t>SKT 개발 — DSX OS MCP 서버 카탈로그 활용 (Phase 3)</a:t>
                       </a:r>
                       <a:endParaRPr lang="en-US" sz="1050" dirty="0">
                         <a:latin typeface="Malgun Gothic" charset="0"/>
@@ -13457,7 +13457,7 @@
         <p:spPr>
           <a:xfrm>
             <a:off x="698500" y="5740400"/>
-            <a:ext cx="1498600" cy="203200"/>
+            <a:ext cx="1651000" cy="203200"/>
           </a:xfrm>
           <a:prstGeom prst="rect">
             <a:avLst/>
@@ -13498,7 +13498,7 @@
         </p:nvSpPr>
         <p:spPr>
           <a:xfrm>
-            <a:off x="2286000" y="5765800"/>
+            <a:off x="2514600" y="5765800"/>
             <a:ext cx="139700" cy="139700"/>
           </a:xfrm>
           <a:prstGeom prst="rect">
@@ -13523,8 +13523,8 @@
         </p:nvSpPr>
         <p:spPr>
           <a:xfrm>
-            <a:off x="2476500" y="5740400"/>
-            <a:ext cx="1498600" cy="203200"/>
+            <a:off x="2705100" y="5740400"/>
+            <a:ext cx="1143000" cy="203200"/>
           </a:xfrm>
           <a:prstGeom prst="rect">
             <a:avLst/>
@@ -13565,7 +13565,7 @@
         </p:nvSpPr>
         <p:spPr>
           <a:xfrm>
-            <a:off x="4064000" y="5765800"/>
+            <a:off x="4013200" y="5765800"/>
             <a:ext cx="139700" cy="139700"/>
           </a:xfrm>
           <a:prstGeom prst="rect">
@@ -13590,8 +13590,8 @@
         </p:nvSpPr>
         <p:spPr>
           <a:xfrm>
-            <a:off x="4254500" y="5740400"/>
-            <a:ext cx="1498600" cy="203200"/>
+            <a:off x="4203700" y="5740400"/>
+            <a:ext cx="2159000" cy="203200"/>
           </a:xfrm>
           <a:prstGeom prst="rect">
             <a:avLst/>
@@ -13618,7 +13618,7 @@
                 <a:ea typeface="Malgun Gothic" pitchFamily="34" charset="-122"/>
                 <a:cs typeface="Malgun Gothic" pitchFamily="34" charset="-120"/>
               </a:rPr>
-              <a:t>공동 개발</a:t>
+              <a:t>SKT 개발 (DSX OS 활용)</a:t>
             </a:r>
             <a:endParaRPr lang="en-US" sz="1050" dirty="0"/>
           </a:p>
@@ -13851,7 +13851,7 @@
                 <a:ea typeface="Malgun Gothic" pitchFamily="34" charset="-122"/>
                 <a:cs typeface="Malgun Gothic" pitchFamily="34" charset="-120"/>
               </a:rPr>
-              <a:t>SKT 개발 경험 + DSX OS 운영 기능을 결합해 Vera Rubin AI Factory의 E2E 관제를 공동 설계·개발하며, 오늘 3가지를 확정하고자 한다</a:t>
+              <a:t>DSX OS가 제공하는 기반 위에 SKT가 Vera Rubin AI Factory의 E2E 관제를 개발한다 — 오늘 이 구조와 범위 3가지를 확정하고자 한다</a:t>
             </a:r>
             <a:endParaRPr lang="en-US" sz="1750" dirty="0"/>
           </a:p>
@@ -14764,11 +14764,11 @@
             <a:avLst/>
           </a:prstGeom>
           <a:solidFill>
-            <a:srgbClr val="FCEBD2"/>
+            <a:srgbClr val="DEE5EF"/>
           </a:solidFill>
           <a:ln w="25400">
             <a:solidFill>
-              <a:srgbClr val="D97E00"/>
+              <a:srgbClr val="17375E"/>
             </a:solidFill>
             <a:prstDash val="solid"/>
           </a:ln>
@@ -14804,7 +14804,7 @@
             <a:r>
               <a:rPr lang="en-US" sz="1200" b="1" dirty="0">
                 <a:solidFill>
-                  <a:srgbClr val="8A5000"/>
+                  <a:srgbClr val="17375E"/>
                 </a:solidFill>
                 <a:latin typeface="Malgun Gothic" pitchFamily="34" charset="0"/>
                 <a:ea typeface="Malgun Gothic" pitchFamily="34" charset="-122"/>
@@ -14824,7 +14824,7 @@
             <a:r>
               <a:rPr lang="en-US" sz="1200" b="1" dirty="0">
                 <a:solidFill>
-                  <a:srgbClr val="8A5000"/>
+                  <a:srgbClr val="17375E"/>
                 </a:solidFill>
                 <a:latin typeface="Malgun Gothic" pitchFamily="34" charset="0"/>
                 <a:ea typeface="Malgun Gothic" pitchFamily="34" charset="-122"/>
@@ -14863,7 +14863,7 @@
             <a:r>
               <a:rPr lang="en-US" sz="1000" dirty="0">
                 <a:solidFill>
-                  <a:srgbClr val="8A5000"/>
+                  <a:srgbClr val="17375E"/>
                 </a:solidFill>
                 <a:latin typeface="Malgun Gothic" pitchFamily="34" charset="0"/>
                 <a:ea typeface="Malgun Gothic" pitchFamily="34" charset="-122"/>
@@ -14877,7 +14877,7 @@
             <a:r>
               <a:rPr lang="en-US" sz="1000" b="1" dirty="0">
                 <a:solidFill>
-                  <a:srgbClr val="8A5000"/>
+                  <a:srgbClr val="17375E"/>
                 </a:solidFill>
                 <a:latin typeface="Malgun Gothic" pitchFamily="34" charset="0"/>
                 <a:ea typeface="Malgun Gothic" pitchFamily="34" charset="-122"/>
@@ -14898,7 +14898,7 @@
         <p:spPr>
           <a:xfrm>
             <a:off x="6172200" y="2997200"/>
-            <a:ext cx="431800" cy="165100"/>
+            <a:ext cx="762000" cy="165100"/>
           </a:xfrm>
           <a:prstGeom prst="roundRect">
             <a:avLst>
@@ -14906,7 +14906,7 @@
             </a:avLst>
           </a:prstGeom>
           <a:solidFill>
-            <a:srgbClr val="D97E00"/>
+            <a:srgbClr val="17375E"/>
           </a:solidFill>
           <a:ln/>
         </p:spPr>
@@ -14920,7 +14920,7 @@
         <p:spPr>
           <a:xfrm>
             <a:off x="6197600" y="2997200"/>
-            <a:ext cx="381000" cy="165100"/>
+            <a:ext cx="711200" cy="165100"/>
           </a:xfrm>
           <a:prstGeom prst="rect">
             <a:avLst/>
@@ -14947,7 +14947,7 @@
                 <a:ea typeface="Malgun Gothic" pitchFamily="34" charset="-122"/>
                 <a:cs typeface="Malgun Gothic" pitchFamily="34" charset="-120"/>
               </a:rPr>
-              <a:t>공동</a:t>
+              <a:t>SKT 개발</a:t>
             </a:r>
             <a:endParaRPr lang="en-US" sz="850" dirty="0"/>
           </a:p>
@@ -14989,7 +14989,7 @@
                 <a:ea typeface="Malgun Gothic" pitchFamily="34" charset="-122"/>
                 <a:cs typeface="Malgun Gothic" pitchFamily="34" charset="-120"/>
               </a:rPr>
-              <a:t>SKT 역량 × DSX OS 결합 → AI Factory 통합 관제 (상세: 슬라이드 6)</a:t>
+              <a:t>DSX OS 기반 위에 SKT가 개발 — AI Factory 통합 관제 (상세: 슬라이드 6)</a:t>
             </a:r>
             <a:endParaRPr lang="en-US" sz="1000" dirty="0"/>
           </a:p>
@@ -15251,7 +15251,7 @@
                 <a:ea typeface="Malgun Gothic" pitchFamily="34" charset="-122"/>
                 <a:cs typeface="Malgun Gothic" pitchFamily="34" charset="-120"/>
               </a:rPr>
-              <a:t>DSX OS 제공 / SKT 개발 / 공동 개발 경계 확정</a:t>
+              <a:t>DSX OS 제공 기반 / SKT 개발 범위 경계 확정</a:t>
             </a:r>
             <a:endParaRPr lang="en-US" sz="1050" dirty="0"/>
           </a:p>
@@ -21667,7 +21667,7 @@
                           <a:ea typeface="Malgun Gothic" pitchFamily="34" charset="-122"/>
                           <a:cs typeface="Malgun Gothic" pitchFamily="34" charset="-120"/>
                         </a:rPr>
-                        <a:t>MCP 서버 기반 Agentic 운영 (공동)</a:t>
+                        <a:t>SKT 개발 — DSX MCP 서버 활용</a:t>
                       </a:r>
                       <a:endParaRPr lang="en-US" sz="1200" dirty="0"/>
                     </a:p>
@@ -22010,7 +22010,7 @@
                 <a:ea typeface="Malgun Gothic" pitchFamily="34" charset="-122"/>
                 <a:cs typeface="Malgun Gothic" pitchFamily="34" charset="-120"/>
               </a:rPr>
-              <a:t>DSX OS의 Health Automation·MCP 서버·DSX Exchange를 골격으로 Compute–Network–Storage–Facility를 관통하는 E2E 구조를 제안한다</a:t>
+              <a:t>DSX OS가 Compute·Network·Storage·Facility 도메인별 기반 기술을 제공하고, SKT는 그 위에 E2E 관제·분석 레이어를 개발한다</a:t>
             </a:r>
             <a:endParaRPr lang="en-US" sz="1550" dirty="0"/>
           </a:p>
@@ -22024,8 +22024,8 @@
         </p:nvSpPr>
         <p:spPr>
           <a:xfrm>
-            <a:off x="762000" y="1473200"/>
-            <a:ext cx="10160000" cy="660400"/>
+            <a:off x="508000" y="1422400"/>
+            <a:ext cx="11176000" cy="2184400"/>
           </a:xfrm>
           <a:prstGeom prst="rect">
             <a:avLst/>
@@ -22033,9 +22033,9 @@
           <a:solidFill>
             <a:srgbClr val="FFFFFF"/>
           </a:solidFill>
-          <a:ln w="9525">
+          <a:ln w="19050">
             <a:solidFill>
-              <a:srgbClr val="C9D2DE"/>
+              <a:srgbClr val="17375E"/>
             </a:solidFill>
             <a:prstDash val="solid"/>
           </a:ln>
@@ -22049,10 +22049,10 @@
         </p:nvSpPr>
         <p:spPr>
           <a:xfrm>
-            <a:off x="863600" y="1689100"/>
-            <a:ext cx="228600" cy="228600"/>
-          </a:xfrm>
-          <a:prstGeom prst="ellipse">
+            <a:off x="508000" y="1422400"/>
+            <a:ext cx="11176000" cy="304800"/>
+          </a:xfrm>
+          <a:prstGeom prst="rect">
             <a:avLst/>
           </a:prstGeom>
           <a:solidFill>
@@ -22069,8 +22069,8 @@
         </p:nvSpPr>
         <p:spPr>
           <a:xfrm>
-            <a:off x="863600" y="1689100"/>
-            <a:ext cx="228600" cy="228600"/>
+            <a:off x="660400" y="1422400"/>
+            <a:ext cx="8890000" cy="304800"/>
           </a:xfrm>
           <a:prstGeom prst="rect">
             <a:avLst/>
@@ -22082,14 +22082,14 @@
           <a:bodyPr wrap="square" lIns="0" tIns="0" rIns="0" bIns="0" rtlCol="0" anchor="ctr"/>
           <a:lstStyle/>
           <a:p>
-            <a:pPr algn="ctr" indent="0" marL="0">
+            <a:pPr algn="l" indent="0" marL="0">
               <a:lnSpc>
                 <a:spcPct val="115000"/>
               </a:lnSpc>
               <a:buNone/>
             </a:pPr>
             <a:r>
-              <a:rPr lang="en-US" sz="1000" b="1" dirty="0">
+              <a:rPr lang="en-US" sz="1150" b="1" dirty="0">
                 <a:solidFill>
                   <a:srgbClr val="FFFFFF"/>
                 </a:solidFill>
@@ -22097,84 +22097,22 @@
                 <a:ea typeface="Malgun Gothic" pitchFamily="34" charset="-122"/>
                 <a:cs typeface="Malgun Gothic" pitchFamily="34" charset="-120"/>
               </a:rPr>
-              <a:t>5</a:t>
-            </a:r>
-            <a:endParaRPr lang="en-US" sz="1000" dirty="0"/>
-          </a:p>
-        </p:txBody>
-      </p:sp>
-      <p:sp>
-        <p:nvSpPr>
-          <p:cNvPr id="11" name="Text 9"/>
-          <p:cNvSpPr/>
-          <p:nvPr/>
-        </p:nvSpPr>
-        <p:spPr>
-          <a:xfrm>
-            <a:off x="1168400" y="1511300"/>
-            <a:ext cx="1651000" cy="584200"/>
-          </a:xfrm>
-          <a:prstGeom prst="rect">
-            <a:avLst/>
-          </a:prstGeom>
-          <a:noFill/>
-          <a:ln/>
-        </p:spPr>
-        <p:txBody>
-          <a:bodyPr wrap="square" lIns="0" tIns="0" rIns="0" bIns="0" rtlCol="0" anchor="ctr"/>
-          <a:lstStyle/>
-          <a:p>
-            <a:pPr algn="l" indent="0" marL="0">
-              <a:lnSpc>
-                <a:spcPct val="105000"/>
-              </a:lnSpc>
-              <a:buNone/>
-            </a:pPr>
-            <a:r>
-              <a:rPr lang="en-US" sz="1050" b="1" dirty="0">
-                <a:solidFill>
-                  <a:srgbClr val="17375E"/>
-                </a:solidFill>
-                <a:latin typeface="Malgun Gothic" pitchFamily="34" charset="0"/>
-                <a:ea typeface="Malgun Gothic" pitchFamily="34" charset="-122"/>
-                <a:cs typeface="Malgun Gothic" pitchFamily="34" charset="-120"/>
-              </a:rPr>
-              <a:t>시각화·Agentic</a:t>
-            </a:r>
-            <a:endParaRPr lang="en-US" sz="1050" dirty="0"/>
-          </a:p>
-          <a:p>
-            <a:pPr algn="l" indent="0" marL="0">
-              <a:lnSpc>
-                <a:spcPct val="105000"/>
-              </a:lnSpc>
-              <a:buNone/>
-            </a:pPr>
-            <a:r>
-              <a:rPr lang="en-US" sz="1050" b="1" dirty="0">
-                <a:solidFill>
-                  <a:srgbClr val="17375E"/>
-                </a:solidFill>
-                <a:latin typeface="Malgun Gothic" pitchFamily="34" charset="0"/>
-                <a:ea typeface="Malgun Gothic" pitchFamily="34" charset="-122"/>
-                <a:cs typeface="Malgun Gothic" pitchFamily="34" charset="-120"/>
-              </a:rPr>
-              <a:t>운영</a:t>
-            </a:r>
-            <a:endParaRPr lang="en-US" sz="1050" dirty="0"/>
-          </a:p>
-        </p:txBody>
-      </p:sp>
-      <p:sp>
-        <p:nvSpPr>
-          <p:cNvPr id="12" name="Shape 10"/>
-          <p:cNvSpPr/>
-          <p:nvPr/>
-        </p:nvSpPr>
-        <p:spPr>
-          <a:xfrm>
-            <a:off x="2946400" y="1574800"/>
-            <a:ext cx="3810000" cy="457200"/>
+              <a:t>SKT 개발 레이어 — E2E Observability (개발 주체: SKT)</a:t>
+            </a:r>
+            <a:endParaRPr lang="en-US" sz="1150" dirty="0"/>
+          </a:p>
+        </p:txBody>
+      </p:sp>
+      <p:sp>
+        <p:nvSpPr>
+          <p:cNvPr id="11" name="Shape 9"/>
+          <p:cNvSpPr/>
+          <p:nvPr/>
+        </p:nvSpPr>
+        <p:spPr>
+          <a:xfrm>
+            <a:off x="711200" y="1828800"/>
+            <a:ext cx="5334000" cy="431800"/>
           </a:xfrm>
           <a:prstGeom prst="rect">
             <a:avLst/>
@@ -22192,14 +22130,14 @@
       </p:sp>
       <p:sp>
         <p:nvSpPr>
-          <p:cNvPr id="13" name="Text 11"/>
-          <p:cNvSpPr/>
-          <p:nvPr/>
-        </p:nvSpPr>
-        <p:spPr>
-          <a:xfrm>
-            <a:off x="2997200" y="1600200"/>
-            <a:ext cx="3708400" cy="406400"/>
+          <p:cNvPr id="12" name="Text 10"/>
+          <p:cNvSpPr/>
+          <p:nvPr/>
+        </p:nvSpPr>
+        <p:spPr>
+          <a:xfrm>
+            <a:off x="762000" y="1854200"/>
+            <a:ext cx="5232400" cy="381000"/>
           </a:xfrm>
           <a:prstGeom prst="rect">
             <a:avLst/>
@@ -22218,7 +22156,7 @@
               <a:buNone/>
             </a:pPr>
             <a:r>
-              <a:rPr lang="en-US" sz="1100" b="1" dirty="0">
+              <a:rPr lang="en-US" sz="1050" b="1" dirty="0">
                 <a:solidFill>
                   <a:srgbClr val="17375E"/>
                 </a:solidFill>
@@ -22226,22 +22164,22 @@
                 <a:ea typeface="Malgun Gothic" pitchFamily="34" charset="-122"/>
                 <a:cs typeface="Malgun Gothic" pitchFamily="34" charset="-120"/>
               </a:rPr>
-              <a:t>E2E 통합 대시보드</a:t>
-            </a:r>
-            <a:endParaRPr lang="en-US" sz="1100" dirty="0"/>
-          </a:p>
-        </p:txBody>
-      </p:sp>
-      <p:sp>
-        <p:nvSpPr>
-          <p:cNvPr id="14" name="Shape 12"/>
-          <p:cNvSpPr/>
-          <p:nvPr/>
-        </p:nvSpPr>
-        <p:spPr>
-          <a:xfrm>
-            <a:off x="7112000" y="1574800"/>
-            <a:ext cx="3657600" cy="457200"/>
+              <a:t>E2E 통합 대시보드 (Multi-DC 통합 관제)</a:t>
+            </a:r>
+            <a:endParaRPr lang="en-US" sz="1050" dirty="0"/>
+          </a:p>
+        </p:txBody>
+      </p:sp>
+      <p:sp>
+        <p:nvSpPr>
+          <p:cNvPr id="13" name="Shape 11"/>
+          <p:cNvSpPr/>
+          <p:nvPr/>
+        </p:nvSpPr>
+        <p:spPr>
+          <a:xfrm>
+            <a:off x="6223000" y="1828800"/>
+            <a:ext cx="5257800" cy="431800"/>
           </a:xfrm>
           <a:prstGeom prst="rect">
             <a:avLst/>
@@ -22259,14 +22197,14 @@
       </p:sp>
       <p:sp>
         <p:nvSpPr>
-          <p:cNvPr id="15" name="Text 13"/>
-          <p:cNvSpPr/>
-          <p:nvPr/>
-        </p:nvSpPr>
-        <p:spPr>
-          <a:xfrm>
-            <a:off x="7162800" y="1600200"/>
-            <a:ext cx="3556000" cy="406400"/>
+          <p:cNvPr id="14" name="Text 12"/>
+          <p:cNvSpPr/>
+          <p:nvPr/>
+        </p:nvSpPr>
+        <p:spPr>
+          <a:xfrm>
+            <a:off x="6273800" y="1854200"/>
+            <a:ext cx="5156200" cy="381000"/>
           </a:xfrm>
           <a:prstGeom prst="rect">
             <a:avLst/>
@@ -22285,7 +22223,7 @@
               <a:buNone/>
             </a:pPr>
             <a:r>
-              <a:rPr lang="en-US" sz="1100" b="1" dirty="0">
+              <a:rPr lang="en-US" sz="1050" b="1" dirty="0">
                 <a:solidFill>
                   <a:srgbClr val="8A5000"/>
                 </a:solidFill>
@@ -22293,53 +22231,577 @@
                 <a:ea typeface="Malgun Gothic" pitchFamily="34" charset="-122"/>
                 <a:cs typeface="Malgun Gothic" pitchFamily="34" charset="-120"/>
               </a:rPr>
-              <a:t>대화형 운영 AI 에이전트</a:t>
-            </a:r>
-            <a:endParaRPr lang="en-US" sz="1100" dirty="0"/>
-          </a:p>
-        </p:txBody>
-      </p:sp>
-      <p:sp>
-        <p:nvSpPr>
-          <p:cNvPr id="16" name="Shape 14"/>
-          <p:cNvSpPr/>
-          <p:nvPr/>
-        </p:nvSpPr>
-        <p:spPr>
-          <a:xfrm>
-            <a:off x="6756400" y="1803400"/>
-            <a:ext cx="355600" cy="0"/>
-          </a:xfrm>
-          <a:prstGeom prst="line">
+              <a:t>운영 AI 에이전트 — DSX MCP 서버 카탈로그 활용</a:t>
+            </a:r>
+            <a:endParaRPr lang="en-US" sz="1050" dirty="0"/>
+          </a:p>
+        </p:txBody>
+      </p:sp>
+      <p:sp>
+        <p:nvSpPr>
+          <p:cNvPr id="15" name="Shape 13"/>
+          <p:cNvSpPr/>
+          <p:nvPr/>
+        </p:nvSpPr>
+        <p:spPr>
+          <a:xfrm>
+            <a:off x="711200" y="2362200"/>
+            <a:ext cx="2616200" cy="508000"/>
+          </a:xfrm>
+          <a:prstGeom prst="rect">
+            <a:avLst/>
+          </a:prstGeom>
+          <a:solidFill>
+            <a:srgbClr val="DEE5EF"/>
+          </a:solidFill>
+          <a:ln w="15875">
+            <a:solidFill>
+              <a:srgbClr val="17375E"/>
+            </a:solidFill>
+            <a:prstDash val="solid"/>
+          </a:ln>
+        </p:spPr>
+      </p:sp>
+      <p:sp>
+        <p:nvSpPr>
+          <p:cNvPr id="16" name="Text 14"/>
+          <p:cNvSpPr/>
+          <p:nvPr/>
+        </p:nvSpPr>
+        <p:spPr>
+          <a:xfrm>
+            <a:off x="762000" y="2387600"/>
+            <a:ext cx="2514600" cy="457200"/>
+          </a:xfrm>
+          <a:prstGeom prst="rect">
             <a:avLst/>
           </a:prstGeom>
           <a:noFill/>
-          <a:ln w="19050">
+          <a:ln/>
+        </p:spPr>
+        <p:txBody>
+          <a:bodyPr wrap="square" lIns="0" tIns="0" rIns="0" bIns="0" rtlCol="0" anchor="ctr"/>
+          <a:lstStyle/>
+          <a:p>
+            <a:pPr algn="ctr" indent="0" marL="0">
+              <a:lnSpc>
+                <a:spcPct val="105000"/>
+              </a:lnSpc>
+              <a:buNone/>
+            </a:pPr>
+            <a:r>
+              <a:rPr lang="en-US" sz="950" b="1" dirty="0">
+                <a:solidFill>
+                  <a:srgbClr val="17375E"/>
+                </a:solidFill>
+                <a:latin typeface="Malgun Gothic" pitchFamily="34" charset="0"/>
+                <a:ea typeface="Malgun Gothic" pitchFamily="34" charset="-122"/>
+                <a:cs typeface="Malgun Gothic" pitchFamily="34" charset="-120"/>
+              </a:rPr>
+              <a:t>이상 탐지·성능 저하 분석</a:t>
+            </a:r>
+            <a:endParaRPr lang="en-US" sz="950" dirty="0"/>
+          </a:p>
+        </p:txBody>
+      </p:sp>
+      <p:sp>
+        <p:nvSpPr>
+          <p:cNvPr id="17" name="Shape 15"/>
+          <p:cNvSpPr/>
+          <p:nvPr/>
+        </p:nvSpPr>
+        <p:spPr>
+          <a:xfrm>
+            <a:off x="3429000" y="2362200"/>
+            <a:ext cx="1930400" cy="508000"/>
+          </a:xfrm>
+          <a:prstGeom prst="rect">
+            <a:avLst/>
+          </a:prstGeom>
+          <a:solidFill>
+            <a:srgbClr val="DEE5EF"/>
+          </a:solidFill>
+          <a:ln w="15875">
             <a:solidFill>
-              <a:srgbClr val="9CA3AF"/>
+              <a:srgbClr val="17375E"/>
             </a:solidFill>
-            <a:prstDash val="dash"/>
-            <a:headEnd type="none"/>
-            <a:tailEnd type="triangle"/>
+            <a:prstDash val="solid"/>
           </a:ln>
         </p:spPr>
       </p:sp>
       <p:sp>
         <p:nvSpPr>
-          <p:cNvPr id="17" name="Shape 15"/>
-          <p:cNvSpPr/>
-          <p:nvPr/>
-        </p:nvSpPr>
-        <p:spPr>
-          <a:xfrm>
-            <a:off x="762000" y="2260600"/>
-            <a:ext cx="10160000" cy="660400"/>
+          <p:cNvPr id="18" name="Text 16"/>
+          <p:cNvSpPr/>
+          <p:nvPr/>
+        </p:nvSpPr>
+        <p:spPr>
+          <a:xfrm>
+            <a:off x="3479800" y="2387600"/>
+            <a:ext cx="1828800" cy="457200"/>
+          </a:xfrm>
+          <a:prstGeom prst="rect">
+            <a:avLst/>
+          </a:prstGeom>
+          <a:noFill/>
+          <a:ln/>
+        </p:spPr>
+        <p:txBody>
+          <a:bodyPr wrap="square" lIns="0" tIns="0" rIns="0" bIns="0" rtlCol="0" anchor="ctr"/>
+          <a:lstStyle/>
+          <a:p>
+            <a:pPr algn="ctr" indent="0" marL="0">
+              <a:lnSpc>
+                <a:spcPct val="105000"/>
+              </a:lnSpc>
+              <a:buNone/>
+            </a:pPr>
+            <a:r>
+              <a:rPr lang="en-US" sz="900" b="1" dirty="0">
+                <a:solidFill>
+                  <a:srgbClr val="17375E"/>
+                </a:solidFill>
+                <a:latin typeface="Malgun Gothic" pitchFamily="34" charset="0"/>
+                <a:ea typeface="Malgun Gothic" pitchFamily="34" charset="-122"/>
+                <a:cs typeface="Malgun Gothic" pitchFamily="34" charset="-120"/>
+              </a:rPr>
+              <a:t>장애 예측</a:t>
+            </a:r>
+            <a:endParaRPr lang="en-US" sz="900" dirty="0"/>
+          </a:p>
+          <a:p>
+            <a:pPr algn="ctr" indent="0" marL="0">
+              <a:lnSpc>
+                <a:spcPct val="105000"/>
+              </a:lnSpc>
+              <a:buNone/>
+            </a:pPr>
+            <a:r>
+              <a:rPr lang="en-US" sz="900" b="1" dirty="0">
+                <a:solidFill>
+                  <a:srgbClr val="17375E"/>
+                </a:solidFill>
+                <a:latin typeface="Malgun Gothic" pitchFamily="34" charset="0"/>
+                <a:ea typeface="Malgun Gothic" pitchFamily="34" charset="-122"/>
+                <a:cs typeface="Malgun Gothic" pitchFamily="34" charset="-120"/>
+              </a:rPr>
+              <a:t>(ECC/XID 선행 신호)</a:t>
+            </a:r>
+            <a:endParaRPr lang="en-US" sz="900" dirty="0"/>
+          </a:p>
+        </p:txBody>
+      </p:sp>
+      <p:sp>
+        <p:nvSpPr>
+          <p:cNvPr id="19" name="Shape 17"/>
+          <p:cNvSpPr/>
+          <p:nvPr/>
+        </p:nvSpPr>
+        <p:spPr>
+          <a:xfrm>
+            <a:off x="5461000" y="2362200"/>
+            <a:ext cx="3048000" cy="508000"/>
           </a:xfrm>
           <a:prstGeom prst="rect">
             <a:avLst/>
           </a:prstGeom>
           <a:solidFill>
-            <a:srgbClr val="FFFFFF"/>
+            <a:srgbClr val="FCEBD2"/>
+          </a:solidFill>
+          <a:ln w="15875">
+            <a:solidFill>
+              <a:srgbClr val="D97E00"/>
+            </a:solidFill>
+            <a:prstDash val="solid"/>
+          </a:ln>
+        </p:spPr>
+      </p:sp>
+      <p:sp>
+        <p:nvSpPr>
+          <p:cNvPr id="20" name="Text 18"/>
+          <p:cNvSpPr/>
+          <p:nvPr/>
+        </p:nvSpPr>
+        <p:spPr>
+          <a:xfrm>
+            <a:off x="5511800" y="2387600"/>
+            <a:ext cx="2946400" cy="457200"/>
+          </a:xfrm>
+          <a:prstGeom prst="rect">
+            <a:avLst/>
+          </a:prstGeom>
+          <a:noFill/>
+          <a:ln/>
+        </p:spPr>
+        <p:txBody>
+          <a:bodyPr wrap="square" lIns="0" tIns="0" rIns="0" bIns="0" rtlCol="0" anchor="ctr"/>
+          <a:lstStyle/>
+          <a:p>
+            <a:pPr algn="ctr" indent="0" marL="0">
+              <a:lnSpc>
+                <a:spcPct val="105000"/>
+              </a:lnSpc>
+              <a:buNone/>
+            </a:pPr>
+            <a:r>
+              <a:rPr lang="en-US" sz="900" b="1" dirty="0">
+                <a:solidFill>
+                  <a:srgbClr val="8A5000"/>
+                </a:solidFill>
+                <a:latin typeface="Malgun Gothic" pitchFamily="34" charset="0"/>
+                <a:ea typeface="Malgun Gothic" pitchFamily="34" charset="-122"/>
+                <a:cs typeface="Malgun Gothic" pitchFamily="34" charset="-120"/>
+              </a:rPr>
+              <a:t>크로스 도메인 상관분석</a:t>
+            </a:r>
+            <a:endParaRPr lang="en-US" sz="900" dirty="0"/>
+          </a:p>
+          <a:p>
+            <a:pPr algn="ctr" indent="0" marL="0">
+              <a:lnSpc>
+                <a:spcPct val="105000"/>
+              </a:lnSpc>
+              <a:buNone/>
+            </a:pPr>
+            <a:r>
+              <a:rPr lang="en-US" sz="900" b="1" dirty="0">
+                <a:solidFill>
+                  <a:srgbClr val="8A5000"/>
+                </a:solidFill>
+                <a:latin typeface="Malgun Gothic" pitchFamily="34" charset="0"/>
+                <a:ea typeface="Malgun Gothic" pitchFamily="34" charset="-122"/>
+                <a:cs typeface="Malgun Gothic" pitchFamily="34" charset="-120"/>
+              </a:rPr>
+              <a:t>— DSX 도메인 데이터 활용</a:t>
+            </a:r>
+            <a:endParaRPr lang="en-US" sz="900" dirty="0"/>
+          </a:p>
+        </p:txBody>
+      </p:sp>
+      <p:sp>
+        <p:nvSpPr>
+          <p:cNvPr id="21" name="Shape 19"/>
+          <p:cNvSpPr/>
+          <p:nvPr/>
+        </p:nvSpPr>
+        <p:spPr>
+          <a:xfrm>
+            <a:off x="8610600" y="2362200"/>
+            <a:ext cx="2870200" cy="508000"/>
+          </a:xfrm>
+          <a:prstGeom prst="rect">
+            <a:avLst/>
+          </a:prstGeom>
+          <a:solidFill>
+            <a:srgbClr val="FCEBD2"/>
+          </a:solidFill>
+          <a:ln w="15875">
+            <a:solidFill>
+              <a:srgbClr val="D97E00"/>
+            </a:solidFill>
+            <a:prstDash val="solid"/>
+          </a:ln>
+        </p:spPr>
+      </p:sp>
+      <p:sp>
+        <p:nvSpPr>
+          <p:cNvPr id="22" name="Text 20"/>
+          <p:cNvSpPr/>
+          <p:nvPr/>
+        </p:nvSpPr>
+        <p:spPr>
+          <a:xfrm>
+            <a:off x="8661400" y="2387600"/>
+            <a:ext cx="2768600" cy="457200"/>
+          </a:xfrm>
+          <a:prstGeom prst="rect">
+            <a:avLst/>
+          </a:prstGeom>
+          <a:noFill/>
+          <a:ln/>
+        </p:spPr>
+        <p:txBody>
+          <a:bodyPr wrap="square" lIns="0" tIns="0" rIns="0" bIns="0" rtlCol="0" anchor="ctr"/>
+          <a:lstStyle/>
+          <a:p>
+            <a:pPr algn="ctr" indent="0" marL="0">
+              <a:lnSpc>
+                <a:spcPct val="105000"/>
+              </a:lnSpc>
+              <a:buNone/>
+            </a:pPr>
+            <a:r>
+              <a:rPr lang="en-US" sz="900" b="1" dirty="0">
+                <a:solidFill>
+                  <a:srgbClr val="8A5000"/>
+                </a:solidFill>
+                <a:latin typeface="Malgun Gothic" pitchFamily="34" charset="0"/>
+                <a:ea typeface="Malgun Gothic" pitchFamily="34" charset="-122"/>
+                <a:cs typeface="Malgun Gothic" pitchFamily="34" charset="-120"/>
+              </a:rPr>
+              <a:t>Facility-aware 상관</a:t>
+            </a:r>
+            <a:endParaRPr lang="en-US" sz="900" dirty="0"/>
+          </a:p>
+          <a:p>
+            <a:pPr algn="ctr" indent="0" marL="0">
+              <a:lnSpc>
+                <a:spcPct val="105000"/>
+              </a:lnSpc>
+              <a:buNone/>
+            </a:pPr>
+            <a:r>
+              <a:rPr lang="en-US" sz="900" b="1" dirty="0">
+                <a:solidFill>
+                  <a:srgbClr val="8A5000"/>
+                </a:solidFill>
+                <a:latin typeface="Malgun Gothic" pitchFamily="34" charset="0"/>
+                <a:ea typeface="Malgun Gothic" pitchFamily="34" charset="-122"/>
+                <a:cs typeface="Malgun Gothic" pitchFamily="34" charset="-120"/>
+              </a:rPr>
+              <a:t>— DSX Exchange 데이터 활용</a:t>
+            </a:r>
+            <a:endParaRPr lang="en-US" sz="900" dirty="0"/>
+          </a:p>
+        </p:txBody>
+      </p:sp>
+      <p:sp>
+        <p:nvSpPr>
+          <p:cNvPr id="23" name="Shape 21"/>
+          <p:cNvSpPr/>
+          <p:nvPr/>
+        </p:nvSpPr>
+        <p:spPr>
+          <a:xfrm>
+            <a:off x="711200" y="2971800"/>
+            <a:ext cx="2616200" cy="508000"/>
+          </a:xfrm>
+          <a:prstGeom prst="rect">
+            <a:avLst/>
+          </a:prstGeom>
+          <a:solidFill>
+            <a:srgbClr val="DEE5EF"/>
+          </a:solidFill>
+          <a:ln w="15875">
+            <a:solidFill>
+              <a:srgbClr val="17375E"/>
+            </a:solidFill>
+            <a:prstDash val="solid"/>
+          </a:ln>
+        </p:spPr>
+      </p:sp>
+      <p:sp>
+        <p:nvSpPr>
+          <p:cNvPr id="24" name="Text 22"/>
+          <p:cNvSpPr/>
+          <p:nvPr/>
+        </p:nvSpPr>
+        <p:spPr>
+          <a:xfrm>
+            <a:off x="762000" y="2997200"/>
+            <a:ext cx="2514600" cy="457200"/>
+          </a:xfrm>
+          <a:prstGeom prst="rect">
+            <a:avLst/>
+          </a:prstGeom>
+          <a:noFill/>
+          <a:ln/>
+        </p:spPr>
+        <p:txBody>
+          <a:bodyPr wrap="square" lIns="0" tIns="0" rIns="0" bIns="0" rtlCol="0" anchor="ctr"/>
+          <a:lstStyle/>
+          <a:p>
+            <a:pPr algn="ctr" indent="0" marL="0">
+              <a:lnSpc>
+                <a:spcPct val="105000"/>
+              </a:lnSpc>
+              <a:buNone/>
+            </a:pPr>
+            <a:r>
+              <a:rPr lang="en-US" sz="950" b="1" dirty="0">
+                <a:solidFill>
+                  <a:srgbClr val="17375E"/>
+                </a:solidFill>
+                <a:latin typeface="Malgun Gothic" pitchFamily="34" charset="0"/>
+                <a:ea typeface="Malgun Gothic" pitchFamily="34" charset="-122"/>
+                <a:cs typeface="Malgun Gothic" pitchFamily="34" charset="-120"/>
+              </a:rPr>
+              <a:t>시계열 DB·저장소</a:t>
+            </a:r>
+            <a:endParaRPr lang="en-US" sz="950" dirty="0"/>
+          </a:p>
+        </p:txBody>
+      </p:sp>
+      <p:sp>
+        <p:nvSpPr>
+          <p:cNvPr id="25" name="Shape 23"/>
+          <p:cNvSpPr/>
+          <p:nvPr/>
+        </p:nvSpPr>
+        <p:spPr>
+          <a:xfrm>
+            <a:off x="3429000" y="2971800"/>
+            <a:ext cx="5080000" cy="508000"/>
+          </a:xfrm>
+          <a:prstGeom prst="rect">
+            <a:avLst/>
+          </a:prstGeom>
+          <a:solidFill>
+            <a:srgbClr val="FCEBD2"/>
+          </a:solidFill>
+          <a:ln w="15875">
+            <a:solidFill>
+              <a:srgbClr val="D97E00"/>
+            </a:solidFill>
+            <a:prstDash val="solid"/>
+          </a:ln>
+        </p:spPr>
+      </p:sp>
+      <p:sp>
+        <p:nvSpPr>
+          <p:cNvPr id="26" name="Text 24"/>
+          <p:cNvSpPr/>
+          <p:nvPr/>
+        </p:nvSpPr>
+        <p:spPr>
+          <a:xfrm>
+            <a:off x="3479800" y="2997200"/>
+            <a:ext cx="4978400" cy="457200"/>
+          </a:xfrm>
+          <a:prstGeom prst="rect">
+            <a:avLst/>
+          </a:prstGeom>
+          <a:noFill/>
+          <a:ln/>
+        </p:spPr>
+        <p:txBody>
+          <a:bodyPr wrap="square" lIns="0" tIns="0" rIns="0" bIns="0" rtlCol="0" anchor="ctr"/>
+          <a:lstStyle/>
+          <a:p>
+            <a:pPr algn="ctr" indent="0" marL="0">
+              <a:lnSpc>
+                <a:spcPct val="105000"/>
+              </a:lnSpc>
+              <a:buNone/>
+            </a:pPr>
+            <a:r>
+              <a:rPr lang="en-US" sz="950" b="1" dirty="0">
+                <a:solidFill>
+                  <a:srgbClr val="8A5000"/>
+                </a:solidFill>
+                <a:latin typeface="Malgun Gothic" pitchFamily="34" charset="0"/>
+                <a:ea typeface="Malgun Gothic" pitchFamily="34" charset="-122"/>
+                <a:cs typeface="Malgun Gothic" pitchFamily="34" charset="-120"/>
+              </a:rPr>
+              <a:t>OTel 수집·통합 파이프라인 — DSX 도메인 소스 연동</a:t>
+            </a:r>
+            <a:endParaRPr lang="en-US" sz="950" dirty="0"/>
+          </a:p>
+        </p:txBody>
+      </p:sp>
+      <p:sp>
+        <p:nvSpPr>
+          <p:cNvPr id="27" name="Shape 25"/>
+          <p:cNvSpPr/>
+          <p:nvPr/>
+        </p:nvSpPr>
+        <p:spPr>
+          <a:xfrm>
+            <a:off x="8610600" y="2971800"/>
+            <a:ext cx="2870200" cy="508000"/>
+          </a:xfrm>
+          <a:prstGeom prst="rect">
+            <a:avLst/>
+          </a:prstGeom>
+          <a:solidFill>
+            <a:srgbClr val="DEE5EF"/>
+          </a:solidFill>
+          <a:ln w="15875">
+            <a:solidFill>
+              <a:srgbClr val="17375E"/>
+            </a:solidFill>
+            <a:prstDash val="solid"/>
+          </a:ln>
+        </p:spPr>
+      </p:sp>
+      <p:sp>
+        <p:nvSpPr>
+          <p:cNvPr id="28" name="Text 26"/>
+          <p:cNvSpPr/>
+          <p:nvPr/>
+        </p:nvSpPr>
+        <p:spPr>
+          <a:xfrm>
+            <a:off x="8661400" y="2997200"/>
+            <a:ext cx="2768600" cy="457200"/>
+          </a:xfrm>
+          <a:prstGeom prst="rect">
+            <a:avLst/>
+          </a:prstGeom>
+          <a:noFill/>
+          <a:ln/>
+        </p:spPr>
+        <p:txBody>
+          <a:bodyPr wrap="square" lIns="0" tIns="0" rIns="0" bIns="0" rtlCol="0" anchor="ctr"/>
+          <a:lstStyle/>
+          <a:p>
+            <a:pPr algn="ctr" indent="0" marL="0">
+              <a:lnSpc>
+                <a:spcPct val="105000"/>
+              </a:lnSpc>
+              <a:buNone/>
+            </a:pPr>
+            <a:r>
+              <a:rPr lang="en-US" sz="900" b="1" dirty="0">
+                <a:solidFill>
+                  <a:srgbClr val="17375E"/>
+                </a:solidFill>
+                <a:latin typeface="Malgun Gothic" pitchFamily="34" charset="0"/>
+                <a:ea typeface="Malgun Gothic" pitchFamily="34" charset="-122"/>
+                <a:cs typeface="Malgun Gothic" pitchFamily="34" charset="-120"/>
+              </a:rPr>
+              <a:t>OOB 수집기 (BMC+Redfish)</a:t>
+            </a:r>
+            <a:endParaRPr lang="en-US" sz="900" dirty="0"/>
+          </a:p>
+          <a:p>
+            <a:pPr algn="ctr" indent="0" marL="0">
+              <a:lnSpc>
+                <a:spcPct val="105000"/>
+              </a:lnSpc>
+              <a:buNone/>
+            </a:pPr>
+            <a:r>
+              <a:rPr lang="en-US" sz="900" b="1" dirty="0">
+                <a:solidFill>
+                  <a:srgbClr val="17375E"/>
+                </a:solidFill>
+                <a:latin typeface="Malgun Gothic" pitchFamily="34" charset="0"/>
+                <a:ea typeface="Malgun Gothic" pitchFamily="34" charset="-122"/>
+                <a:cs typeface="Malgun Gothic" pitchFamily="34" charset="-120"/>
+              </a:rPr>
+              <a:t>— 전 도메인 횡단, SKT 자체</a:t>
+            </a:r>
+            <a:endParaRPr lang="en-US" sz="900" dirty="0"/>
+          </a:p>
+        </p:txBody>
+      </p:sp>
+      <p:sp>
+        <p:nvSpPr>
+          <p:cNvPr id="29" name="Shape 27"/>
+          <p:cNvSpPr/>
+          <p:nvPr/>
+        </p:nvSpPr>
+        <p:spPr>
+          <a:xfrm>
+            <a:off x="508000" y="3759200"/>
+            <a:ext cx="11176000" cy="279400"/>
+          </a:xfrm>
+          <a:prstGeom prst="rect">
+            <a:avLst/>
+          </a:prstGeom>
+          <a:solidFill>
+            <a:srgbClr val="F1F3F5"/>
           </a:solidFill>
           <a:ln w="9525">
             <a:solidFill>
@@ -22351,34 +22813,14 @@
       </p:sp>
       <p:sp>
         <p:nvSpPr>
-          <p:cNvPr id="18" name="Shape 16"/>
-          <p:cNvSpPr/>
-          <p:nvPr/>
-        </p:nvSpPr>
-        <p:spPr>
-          <a:xfrm>
-            <a:off x="863600" y="2476500"/>
-            <a:ext cx="228600" cy="228600"/>
-          </a:xfrm>
-          <a:prstGeom prst="ellipse">
-            <a:avLst/>
-          </a:prstGeom>
-          <a:solidFill>
-            <a:srgbClr val="17375E"/>
-          </a:solidFill>
-          <a:ln/>
-        </p:spPr>
-      </p:sp>
-      <p:sp>
-        <p:nvSpPr>
-          <p:cNvPr id="19" name="Text 17"/>
-          <p:cNvSpPr/>
-          <p:nvPr/>
-        </p:nvSpPr>
-        <p:spPr>
-          <a:xfrm>
-            <a:off x="863600" y="2476500"/>
-            <a:ext cx="228600" cy="228600"/>
+          <p:cNvPr id="30" name="Text 28"/>
+          <p:cNvSpPr/>
+          <p:nvPr/>
+        </p:nvSpPr>
+        <p:spPr>
+          <a:xfrm>
+            <a:off x="508000" y="3759200"/>
+            <a:ext cx="11176000" cy="279400"/>
           </a:xfrm>
           <a:prstGeom prst="rect">
             <a:avLst/>
@@ -22399,13 +22841,13 @@
             <a:r>
               <a:rPr lang="en-US" sz="1000" b="1" dirty="0">
                 <a:solidFill>
-                  <a:srgbClr val="FFFFFF"/>
-                </a:solidFill>
-                <a:latin typeface="Malgun Gothic" pitchFamily="34" charset="0"/>
-                <a:ea typeface="Malgun Gothic" pitchFamily="34" charset="-122"/>
-                <a:cs typeface="Malgun Gothic" pitchFamily="34" charset="-120"/>
-              </a:rPr>
-              <a:t>4</a:t>
+                  <a:srgbClr val="4B5563"/>
+                </a:solidFill>
+                <a:latin typeface="Malgun Gothic" pitchFamily="34" charset="0"/>
+                <a:ea typeface="Malgun Gothic" pitchFamily="34" charset="-122"/>
+                <a:cs typeface="Malgun Gothic" pitchFamily="34" charset="-120"/>
+              </a:rPr>
+              <a:t>표준 인터페이스:  OpenTelemetry (CNCF)  ·  Redfish (DMTF)  ·  MQTT  ·  MCP</a:t>
             </a:r>
             <a:endParaRPr lang="en-US" sz="1000" dirty="0"/>
           </a:p>
@@ -22413,14 +22855,259 @@
       </p:sp>
       <p:sp>
         <p:nvSpPr>
-          <p:cNvPr id="20" name="Text 18"/>
-          <p:cNvSpPr/>
-          <p:nvPr/>
-        </p:nvSpPr>
-        <p:spPr>
-          <a:xfrm>
-            <a:off x="1168400" y="2298700"/>
-            <a:ext cx="1651000" cy="584200"/>
+          <p:cNvPr id="31" name="Shape 29"/>
+          <p:cNvSpPr/>
+          <p:nvPr/>
+        </p:nvSpPr>
+        <p:spPr>
+          <a:xfrm flipV="1">
+            <a:off x="1905000" y="3606800"/>
+            <a:ext cx="0" cy="152400"/>
+          </a:xfrm>
+          <a:prstGeom prst="line">
+            <a:avLst/>
+          </a:prstGeom>
+          <a:noFill/>
+          <a:ln w="19050">
+            <a:solidFill>
+              <a:srgbClr val="9CA3AF"/>
+            </a:solidFill>
+            <a:prstDash val="solid"/>
+            <a:headEnd type="none"/>
+            <a:tailEnd type="triangle"/>
+          </a:ln>
+        </p:spPr>
+      </p:sp>
+      <p:sp>
+        <p:nvSpPr>
+          <p:cNvPr id="32" name="Shape 30"/>
+          <p:cNvSpPr/>
+          <p:nvPr/>
+        </p:nvSpPr>
+        <p:spPr>
+          <a:xfrm flipV="1">
+            <a:off x="4953000" y="3606800"/>
+            <a:ext cx="0" cy="152400"/>
+          </a:xfrm>
+          <a:prstGeom prst="line">
+            <a:avLst/>
+          </a:prstGeom>
+          <a:noFill/>
+          <a:ln w="19050">
+            <a:solidFill>
+              <a:srgbClr val="9CA3AF"/>
+            </a:solidFill>
+            <a:prstDash val="solid"/>
+            <a:headEnd type="none"/>
+            <a:tailEnd type="triangle"/>
+          </a:ln>
+        </p:spPr>
+      </p:sp>
+      <p:sp>
+        <p:nvSpPr>
+          <p:cNvPr id="33" name="Shape 31"/>
+          <p:cNvSpPr/>
+          <p:nvPr/>
+        </p:nvSpPr>
+        <p:spPr>
+          <a:xfrm flipV="1">
+            <a:off x="8001000" y="3606800"/>
+            <a:ext cx="0" cy="152400"/>
+          </a:xfrm>
+          <a:prstGeom prst="line">
+            <a:avLst/>
+          </a:prstGeom>
+          <a:noFill/>
+          <a:ln w="19050">
+            <a:solidFill>
+              <a:srgbClr val="9CA3AF"/>
+            </a:solidFill>
+            <a:prstDash val="solid"/>
+            <a:headEnd type="none"/>
+            <a:tailEnd type="triangle"/>
+          </a:ln>
+        </p:spPr>
+      </p:sp>
+      <p:sp>
+        <p:nvSpPr>
+          <p:cNvPr id="34" name="Shape 32"/>
+          <p:cNvSpPr/>
+          <p:nvPr/>
+        </p:nvSpPr>
+        <p:spPr>
+          <a:xfrm flipV="1">
+            <a:off x="10541000" y="3606800"/>
+            <a:ext cx="0" cy="152400"/>
+          </a:xfrm>
+          <a:prstGeom prst="line">
+            <a:avLst/>
+          </a:prstGeom>
+          <a:noFill/>
+          <a:ln w="19050">
+            <a:solidFill>
+              <a:srgbClr val="9CA3AF"/>
+            </a:solidFill>
+            <a:prstDash val="solid"/>
+            <a:headEnd type="none"/>
+            <a:tailEnd type="triangle"/>
+          </a:ln>
+        </p:spPr>
+      </p:sp>
+      <p:sp>
+        <p:nvSpPr>
+          <p:cNvPr id="35" name="Shape 33"/>
+          <p:cNvSpPr/>
+          <p:nvPr/>
+        </p:nvSpPr>
+        <p:spPr>
+          <a:xfrm flipV="1">
+            <a:off x="1905000" y="4038600"/>
+            <a:ext cx="0" cy="152400"/>
+          </a:xfrm>
+          <a:prstGeom prst="line">
+            <a:avLst/>
+          </a:prstGeom>
+          <a:noFill/>
+          <a:ln w="19050">
+            <a:solidFill>
+              <a:srgbClr val="9CA3AF"/>
+            </a:solidFill>
+            <a:prstDash val="solid"/>
+            <a:headEnd type="none"/>
+            <a:tailEnd type="triangle"/>
+          </a:ln>
+        </p:spPr>
+      </p:sp>
+      <p:sp>
+        <p:nvSpPr>
+          <p:cNvPr id="36" name="Shape 34"/>
+          <p:cNvSpPr/>
+          <p:nvPr/>
+        </p:nvSpPr>
+        <p:spPr>
+          <a:xfrm flipV="1">
+            <a:off x="4953000" y="4038600"/>
+            <a:ext cx="0" cy="152400"/>
+          </a:xfrm>
+          <a:prstGeom prst="line">
+            <a:avLst/>
+          </a:prstGeom>
+          <a:noFill/>
+          <a:ln w="19050">
+            <a:solidFill>
+              <a:srgbClr val="9CA3AF"/>
+            </a:solidFill>
+            <a:prstDash val="solid"/>
+            <a:headEnd type="none"/>
+            <a:tailEnd type="triangle"/>
+          </a:ln>
+        </p:spPr>
+      </p:sp>
+      <p:sp>
+        <p:nvSpPr>
+          <p:cNvPr id="37" name="Shape 35"/>
+          <p:cNvSpPr/>
+          <p:nvPr/>
+        </p:nvSpPr>
+        <p:spPr>
+          <a:xfrm flipV="1">
+            <a:off x="8001000" y="4038600"/>
+            <a:ext cx="0" cy="152400"/>
+          </a:xfrm>
+          <a:prstGeom prst="line">
+            <a:avLst/>
+          </a:prstGeom>
+          <a:noFill/>
+          <a:ln w="19050">
+            <a:solidFill>
+              <a:srgbClr val="9CA3AF"/>
+            </a:solidFill>
+            <a:prstDash val="solid"/>
+            <a:headEnd type="none"/>
+            <a:tailEnd type="triangle"/>
+          </a:ln>
+        </p:spPr>
+      </p:sp>
+      <p:sp>
+        <p:nvSpPr>
+          <p:cNvPr id="38" name="Shape 36"/>
+          <p:cNvSpPr/>
+          <p:nvPr/>
+        </p:nvSpPr>
+        <p:spPr>
+          <a:xfrm flipV="1">
+            <a:off x="10541000" y="4038600"/>
+            <a:ext cx="0" cy="152400"/>
+          </a:xfrm>
+          <a:prstGeom prst="line">
+            <a:avLst/>
+          </a:prstGeom>
+          <a:noFill/>
+          <a:ln w="19050">
+            <a:solidFill>
+              <a:srgbClr val="9CA3AF"/>
+            </a:solidFill>
+            <a:prstDash val="solid"/>
+            <a:headEnd type="none"/>
+            <a:tailEnd type="triangle"/>
+          </a:ln>
+        </p:spPr>
+      </p:sp>
+      <p:sp>
+        <p:nvSpPr>
+          <p:cNvPr id="39" name="Shape 37"/>
+          <p:cNvSpPr/>
+          <p:nvPr/>
+        </p:nvSpPr>
+        <p:spPr>
+          <a:xfrm>
+            <a:off x="508000" y="4191000"/>
+            <a:ext cx="11176000" cy="1752600"/>
+          </a:xfrm>
+          <a:prstGeom prst="rect">
+            <a:avLst/>
+          </a:prstGeom>
+          <a:solidFill>
+            <a:srgbClr val="FFFFFF"/>
+          </a:solidFill>
+          <a:ln w="19050">
+            <a:solidFill>
+              <a:srgbClr val="76B900"/>
+            </a:solidFill>
+            <a:prstDash val="solid"/>
+          </a:ln>
+        </p:spPr>
+      </p:sp>
+      <p:sp>
+        <p:nvSpPr>
+          <p:cNvPr id="40" name="Shape 38"/>
+          <p:cNvSpPr/>
+          <p:nvPr/>
+        </p:nvSpPr>
+        <p:spPr>
+          <a:xfrm>
+            <a:off x="508000" y="4191000"/>
+            <a:ext cx="11176000" cy="304800"/>
+          </a:xfrm>
+          <a:prstGeom prst="rect">
+            <a:avLst/>
+          </a:prstGeom>
+          <a:solidFill>
+            <a:srgbClr val="76B900"/>
+          </a:solidFill>
+          <a:ln/>
+        </p:spPr>
+      </p:sp>
+      <p:sp>
+        <p:nvSpPr>
+          <p:cNvPr id="41" name="Text 39"/>
+          <p:cNvSpPr/>
+          <p:nvPr/>
+        </p:nvSpPr>
+        <p:spPr>
+          <a:xfrm>
+            <a:off x="660400" y="4191000"/>
+            <a:ext cx="9652000" cy="304800"/>
           </a:xfrm>
           <a:prstGeom prst="rect">
             <a:avLst/>
@@ -22434,35 +23121,102 @@
           <a:p>
             <a:pPr algn="l" indent="0" marL="0">
               <a:lnSpc>
-                <a:spcPct val="105000"/>
+                <a:spcPct val="115000"/>
               </a:lnSpc>
               <a:buNone/>
             </a:pPr>
             <a:r>
-              <a:rPr lang="en-US" sz="1050" b="1" dirty="0">
-                <a:solidFill>
-                  <a:srgbClr val="17375E"/>
-                </a:solidFill>
-                <a:latin typeface="Malgun Gothic" pitchFamily="34" charset="0"/>
-                <a:ea typeface="Malgun Gothic" pitchFamily="34" charset="-122"/>
-                <a:cs typeface="Malgun Gothic" pitchFamily="34" charset="-120"/>
-              </a:rPr>
-              <a:t>분석</a:t>
-            </a:r>
-            <a:endParaRPr lang="en-US" sz="1050" dirty="0"/>
-          </a:p>
-        </p:txBody>
-      </p:sp>
-      <p:sp>
-        <p:nvSpPr>
-          <p:cNvPr id="21" name="Shape 19"/>
-          <p:cNvSpPr/>
-          <p:nvPr/>
-        </p:nvSpPr>
-        <p:spPr>
-          <a:xfrm>
-            <a:off x="2946400" y="2362200"/>
-            <a:ext cx="1930400" cy="457200"/>
+              <a:rPr lang="en-US" sz="1150" b="1" dirty="0">
+                <a:solidFill>
+                  <a:srgbClr val="FFFFFF"/>
+                </a:solidFill>
+                <a:latin typeface="Malgun Gothic" pitchFamily="34" charset="0"/>
+                <a:ea typeface="Malgun Gothic" pitchFamily="34" charset="-122"/>
+                <a:cs typeface="Malgun Gothic" pitchFamily="34" charset="-120"/>
+              </a:rPr>
+              <a:t>NVIDIA DSX OS Reference 기반 — 도메인별 제공 기술 (제공 주체: DSX OS·Vera Rubin)</a:t>
+            </a:r>
+            <a:endParaRPr lang="en-US" sz="1150" dirty="0"/>
+          </a:p>
+        </p:txBody>
+      </p:sp>
+      <p:sp>
+        <p:nvSpPr>
+          <p:cNvPr id="42" name="Shape 40"/>
+          <p:cNvSpPr/>
+          <p:nvPr/>
+        </p:nvSpPr>
+        <p:spPr>
+          <a:xfrm>
+            <a:off x="711200" y="4572000"/>
+            <a:ext cx="2540000" cy="228600"/>
+          </a:xfrm>
+          <a:prstGeom prst="rect">
+            <a:avLst/>
+          </a:prstGeom>
+          <a:solidFill>
+            <a:srgbClr val="FFFFFF"/>
+          </a:solidFill>
+          <a:ln w="9525">
+            <a:solidFill>
+              <a:srgbClr val="76B900"/>
+            </a:solidFill>
+            <a:prstDash val="solid"/>
+          </a:ln>
+        </p:spPr>
+      </p:sp>
+      <p:sp>
+        <p:nvSpPr>
+          <p:cNvPr id="43" name="Text 41"/>
+          <p:cNvSpPr/>
+          <p:nvPr/>
+        </p:nvSpPr>
+        <p:spPr>
+          <a:xfrm>
+            <a:off x="711200" y="4572000"/>
+            <a:ext cx="2540000" cy="228600"/>
+          </a:xfrm>
+          <a:prstGeom prst="rect">
+            <a:avLst/>
+          </a:prstGeom>
+          <a:noFill/>
+          <a:ln/>
+        </p:spPr>
+        <p:txBody>
+          <a:bodyPr wrap="square" lIns="0" tIns="0" rIns="0" bIns="0" rtlCol="0" anchor="ctr"/>
+          <a:lstStyle/>
+          <a:p>
+            <a:pPr algn="ctr" indent="0" marL="0">
+              <a:lnSpc>
+                <a:spcPct val="115000"/>
+              </a:lnSpc>
+              <a:buNone/>
+            </a:pPr>
+            <a:r>
+              <a:rPr lang="en-US" sz="1000" b="1" dirty="0">
+                <a:solidFill>
+                  <a:srgbClr val="3E6300"/>
+                </a:solidFill>
+                <a:latin typeface="Malgun Gothic" pitchFamily="34" charset="0"/>
+                <a:ea typeface="Malgun Gothic" pitchFamily="34" charset="-122"/>
+                <a:cs typeface="Malgun Gothic" pitchFamily="34" charset="-120"/>
+              </a:rPr>
+              <a:t>Compute</a:t>
+            </a:r>
+            <a:endParaRPr lang="en-US" sz="1000" dirty="0"/>
+          </a:p>
+        </p:txBody>
+      </p:sp>
+      <p:sp>
+        <p:nvSpPr>
+          <p:cNvPr id="44" name="Shape 42"/>
+          <p:cNvSpPr/>
+          <p:nvPr/>
+        </p:nvSpPr>
+        <p:spPr>
+          <a:xfrm>
+            <a:off x="711200" y="4851400"/>
+            <a:ext cx="2540000" cy="355600"/>
           </a:xfrm>
           <a:prstGeom prst="rect">
             <a:avLst/>
@@ -22480,14 +23234,14 @@
       </p:sp>
       <p:sp>
         <p:nvSpPr>
-          <p:cNvPr id="22" name="Text 20"/>
-          <p:cNvSpPr/>
-          <p:nvPr/>
-        </p:nvSpPr>
-        <p:spPr>
-          <a:xfrm>
-            <a:off x="2997200" y="2387600"/>
-            <a:ext cx="1828800" cy="406400"/>
+          <p:cNvPr id="45" name="Text 43"/>
+          <p:cNvSpPr/>
+          <p:nvPr/>
+        </p:nvSpPr>
+        <p:spPr>
+          <a:xfrm>
+            <a:off x="762000" y="4876800"/>
+            <a:ext cx="2438400" cy="304800"/>
           </a:xfrm>
           <a:prstGeom prst="rect">
             <a:avLst/>
@@ -22506,7 +23260,7 @@
               <a:buNone/>
             </a:pPr>
             <a:r>
-              <a:rPr lang="en-US" sz="900" b="1" dirty="0">
+              <a:rPr lang="en-US" sz="850" b="1" dirty="0">
                 <a:solidFill>
                   <a:srgbClr val="3E6300"/>
                 </a:solidFill>
@@ -22514,824 +23268,22 @@
                 <a:ea typeface="Malgun Gothic" pitchFamily="34" charset="-122"/>
                 <a:cs typeface="Malgun Gothic" pitchFamily="34" charset="-120"/>
               </a:rPr>
-              <a:t>Health Automation</a:t>
-            </a:r>
-            <a:endParaRPr lang="en-US" sz="900" dirty="0"/>
-          </a:p>
-          <a:p>
-            <a:pPr algn="ctr" indent="0" marL="0">
-              <a:lnSpc>
-                <a:spcPct val="105000"/>
-              </a:lnSpc>
-              <a:buNone/>
-            </a:pPr>
-            <a:r>
-              <a:rPr lang="en-US" sz="900" b="1" dirty="0">
-                <a:solidFill>
-                  <a:srgbClr val="3E6300"/>
-                </a:solidFill>
-                <a:latin typeface="Malgun Gothic" pitchFamily="34" charset="0"/>
-                <a:ea typeface="Malgun Gothic" pitchFamily="34" charset="-122"/>
-                <a:cs typeface="Malgun Gothic" pitchFamily="34" charset="-120"/>
-              </a:rPr>
-              <a:t>Resiliency</a:t>
-            </a:r>
-            <a:endParaRPr lang="en-US" sz="900" dirty="0"/>
-          </a:p>
-        </p:txBody>
-      </p:sp>
-      <p:sp>
-        <p:nvSpPr>
-          <p:cNvPr id="23" name="Shape 21"/>
-          <p:cNvSpPr/>
-          <p:nvPr/>
-        </p:nvSpPr>
-        <p:spPr>
-          <a:xfrm>
-            <a:off x="4953000" y="2362200"/>
-            <a:ext cx="1930400" cy="457200"/>
-          </a:xfrm>
-          <a:prstGeom prst="rect">
-            <a:avLst/>
-          </a:prstGeom>
-          <a:solidFill>
-            <a:srgbClr val="DEE5EF"/>
-          </a:solidFill>
-          <a:ln w="15875">
-            <a:solidFill>
-              <a:srgbClr val="17375E"/>
-            </a:solidFill>
-            <a:prstDash val="solid"/>
-          </a:ln>
-        </p:spPr>
-      </p:sp>
-      <p:sp>
-        <p:nvSpPr>
-          <p:cNvPr id="24" name="Text 22"/>
-          <p:cNvSpPr/>
-          <p:nvPr/>
-        </p:nvSpPr>
-        <p:spPr>
-          <a:xfrm>
-            <a:off x="5003800" y="2387600"/>
-            <a:ext cx="1828800" cy="406400"/>
-          </a:xfrm>
-          <a:prstGeom prst="rect">
-            <a:avLst/>
-          </a:prstGeom>
-          <a:noFill/>
-          <a:ln/>
-        </p:spPr>
-        <p:txBody>
-          <a:bodyPr wrap="square" lIns="0" tIns="0" rIns="0" bIns="0" rtlCol="0" anchor="ctr"/>
-          <a:lstStyle/>
-          <a:p>
-            <a:pPr algn="ctr" indent="0" marL="0">
-              <a:lnSpc>
-                <a:spcPct val="105000"/>
-              </a:lnSpc>
-              <a:buNone/>
-            </a:pPr>
-            <a:r>
-              <a:rPr lang="en-US" sz="900" b="1" dirty="0">
-                <a:solidFill>
-                  <a:srgbClr val="17375E"/>
-                </a:solidFill>
-                <a:latin typeface="Malgun Gothic" pitchFamily="34" charset="0"/>
-                <a:ea typeface="Malgun Gothic" pitchFamily="34" charset="-122"/>
-                <a:cs typeface="Malgun Gothic" pitchFamily="34" charset="-120"/>
-              </a:rPr>
-              <a:t>이상 탐지·성능</a:t>
-            </a:r>
-            <a:endParaRPr lang="en-US" sz="900" dirty="0"/>
-          </a:p>
-          <a:p>
-            <a:pPr algn="ctr" indent="0" marL="0">
-              <a:lnSpc>
-                <a:spcPct val="105000"/>
-              </a:lnSpc>
-              <a:buNone/>
-            </a:pPr>
-            <a:r>
-              <a:rPr lang="en-US" sz="900" b="1" dirty="0">
-                <a:solidFill>
-                  <a:srgbClr val="17375E"/>
-                </a:solidFill>
-                <a:latin typeface="Malgun Gothic" pitchFamily="34" charset="0"/>
-                <a:ea typeface="Malgun Gothic" pitchFamily="34" charset="-122"/>
-                <a:cs typeface="Malgun Gothic" pitchFamily="34" charset="-120"/>
-              </a:rPr>
-              <a:t>저하 분석</a:t>
-            </a:r>
-            <a:endParaRPr lang="en-US" sz="900" dirty="0"/>
-          </a:p>
-        </p:txBody>
-      </p:sp>
-      <p:sp>
-        <p:nvSpPr>
-          <p:cNvPr id="25" name="Shape 23"/>
-          <p:cNvSpPr/>
-          <p:nvPr/>
-        </p:nvSpPr>
-        <p:spPr>
-          <a:xfrm>
-            <a:off x="6959600" y="2362200"/>
-            <a:ext cx="1524000" cy="457200"/>
-          </a:xfrm>
-          <a:prstGeom prst="rect">
-            <a:avLst/>
-          </a:prstGeom>
-          <a:solidFill>
-            <a:srgbClr val="DEE5EF"/>
-          </a:solidFill>
-          <a:ln w="15875">
-            <a:solidFill>
-              <a:srgbClr val="17375E"/>
-            </a:solidFill>
-            <a:prstDash val="solid"/>
-          </a:ln>
-        </p:spPr>
-      </p:sp>
-      <p:sp>
-        <p:nvSpPr>
-          <p:cNvPr id="26" name="Text 24"/>
-          <p:cNvSpPr/>
-          <p:nvPr/>
-        </p:nvSpPr>
-        <p:spPr>
-          <a:xfrm>
-            <a:off x="7010400" y="2387600"/>
-            <a:ext cx="1422400" cy="406400"/>
-          </a:xfrm>
-          <a:prstGeom prst="rect">
-            <a:avLst/>
-          </a:prstGeom>
-          <a:noFill/>
-          <a:ln/>
-        </p:spPr>
-        <p:txBody>
-          <a:bodyPr wrap="square" lIns="0" tIns="0" rIns="0" bIns="0" rtlCol="0" anchor="ctr"/>
-          <a:lstStyle/>
-          <a:p>
-            <a:pPr algn="ctr" indent="0" marL="0">
-              <a:lnSpc>
-                <a:spcPct val="105000"/>
-              </a:lnSpc>
-              <a:buNone/>
-            </a:pPr>
-            <a:r>
-              <a:rPr lang="en-US" sz="950" b="1" dirty="0">
-                <a:solidFill>
-                  <a:srgbClr val="17375E"/>
-                </a:solidFill>
-                <a:latin typeface="Malgun Gothic" pitchFamily="34" charset="0"/>
-                <a:ea typeface="Malgun Gothic" pitchFamily="34" charset="-122"/>
-                <a:cs typeface="Malgun Gothic" pitchFamily="34" charset="-120"/>
-              </a:rPr>
-              <a:t>장애 예측</a:t>
-            </a:r>
-            <a:endParaRPr lang="en-US" sz="950" dirty="0"/>
-          </a:p>
-        </p:txBody>
-      </p:sp>
-      <p:sp>
-        <p:nvSpPr>
-          <p:cNvPr id="27" name="Shape 25"/>
-          <p:cNvSpPr/>
-          <p:nvPr/>
-        </p:nvSpPr>
-        <p:spPr>
-          <a:xfrm>
-            <a:off x="8559800" y="2362200"/>
-            <a:ext cx="2209800" cy="457200"/>
-          </a:xfrm>
-          <a:prstGeom prst="rect">
-            <a:avLst/>
-          </a:prstGeom>
-          <a:solidFill>
-            <a:srgbClr val="FCEBD2"/>
-          </a:solidFill>
-          <a:ln w="15875">
-            <a:solidFill>
-              <a:srgbClr val="D97E00"/>
-            </a:solidFill>
-            <a:prstDash val="solid"/>
-          </a:ln>
-        </p:spPr>
-      </p:sp>
-      <p:sp>
-        <p:nvSpPr>
-          <p:cNvPr id="28" name="Text 26"/>
-          <p:cNvSpPr/>
-          <p:nvPr/>
-        </p:nvSpPr>
-        <p:spPr>
-          <a:xfrm>
-            <a:off x="8610600" y="2387600"/>
-            <a:ext cx="2108200" cy="406400"/>
-          </a:xfrm>
-          <a:prstGeom prst="rect">
-            <a:avLst/>
-          </a:prstGeom>
-          <a:noFill/>
-          <a:ln/>
-        </p:spPr>
-        <p:txBody>
-          <a:bodyPr wrap="square" lIns="0" tIns="0" rIns="0" bIns="0" rtlCol="0" anchor="ctr"/>
-          <a:lstStyle/>
-          <a:p>
-            <a:pPr algn="ctr" indent="0" marL="0">
-              <a:lnSpc>
-                <a:spcPct val="105000"/>
-              </a:lnSpc>
-              <a:buNone/>
-            </a:pPr>
-            <a:r>
-              <a:rPr lang="en-US" sz="850" b="1" dirty="0">
-                <a:solidFill>
-                  <a:srgbClr val="8A5000"/>
-                </a:solidFill>
-                <a:latin typeface="Malgun Gothic" pitchFamily="34" charset="0"/>
-                <a:ea typeface="Malgun Gothic" pitchFamily="34" charset="-122"/>
-                <a:cs typeface="Malgun Gothic" pitchFamily="34" charset="-120"/>
-              </a:rPr>
-              <a:t>크로스 도메인 상관분석</a:t>
+              <a:t>DCGM 텔레메트리 (GPU In-band)</a:t>
             </a:r>
             <a:endParaRPr lang="en-US" sz="850" dirty="0"/>
           </a:p>
-          <a:p>
-            <a:pPr algn="ctr" indent="0" marL="0">
-              <a:lnSpc>
-                <a:spcPct val="105000"/>
-              </a:lnSpc>
-              <a:buNone/>
-            </a:pPr>
-            <a:r>
-              <a:rPr lang="en-US" sz="850" b="1" dirty="0">
-                <a:solidFill>
-                  <a:srgbClr val="8A5000"/>
-                </a:solidFill>
-                <a:latin typeface="Malgun Gothic" pitchFamily="34" charset="0"/>
-                <a:ea typeface="Malgun Gothic" pitchFamily="34" charset="-122"/>
-                <a:cs typeface="Malgun Gothic" pitchFamily="34" charset="-120"/>
-              </a:rPr>
-              <a:t>(MCP 서버 카탈로그)</a:t>
-            </a:r>
-            <a:endParaRPr lang="en-US" sz="850" dirty="0"/>
-          </a:p>
-        </p:txBody>
-      </p:sp>
-      <p:sp>
-        <p:nvSpPr>
-          <p:cNvPr id="29" name="Shape 27"/>
-          <p:cNvSpPr/>
-          <p:nvPr/>
-        </p:nvSpPr>
-        <p:spPr>
-          <a:xfrm>
-            <a:off x="762000" y="3048000"/>
-            <a:ext cx="10160000" cy="533400"/>
-          </a:xfrm>
-          <a:prstGeom prst="rect">
-            <a:avLst/>
-          </a:prstGeom>
-          <a:solidFill>
-            <a:srgbClr val="FFFFFF"/>
-          </a:solidFill>
-          <a:ln w="9525">
-            <a:solidFill>
-              <a:srgbClr val="C9D2DE"/>
-            </a:solidFill>
-            <a:prstDash val="solid"/>
-          </a:ln>
-        </p:spPr>
-      </p:sp>
-      <p:sp>
-        <p:nvSpPr>
-          <p:cNvPr id="30" name="Shape 28"/>
-          <p:cNvSpPr/>
-          <p:nvPr/>
-        </p:nvSpPr>
-        <p:spPr>
-          <a:xfrm>
-            <a:off x="863600" y="3200400"/>
-            <a:ext cx="228600" cy="228600"/>
-          </a:xfrm>
-          <a:prstGeom prst="ellipse">
-            <a:avLst/>
-          </a:prstGeom>
-          <a:solidFill>
-            <a:srgbClr val="17375E"/>
-          </a:solidFill>
-          <a:ln/>
-        </p:spPr>
-      </p:sp>
-      <p:sp>
-        <p:nvSpPr>
-          <p:cNvPr id="31" name="Text 29"/>
-          <p:cNvSpPr/>
-          <p:nvPr/>
-        </p:nvSpPr>
-        <p:spPr>
-          <a:xfrm>
-            <a:off x="863600" y="3200400"/>
-            <a:ext cx="228600" cy="228600"/>
-          </a:xfrm>
-          <a:prstGeom prst="rect">
-            <a:avLst/>
-          </a:prstGeom>
-          <a:noFill/>
-          <a:ln/>
-        </p:spPr>
-        <p:txBody>
-          <a:bodyPr wrap="square" lIns="0" tIns="0" rIns="0" bIns="0" rtlCol="0" anchor="ctr"/>
-          <a:lstStyle/>
-          <a:p>
-            <a:pPr algn="ctr" indent="0" marL="0">
-              <a:lnSpc>
-                <a:spcPct val="115000"/>
-              </a:lnSpc>
-              <a:buNone/>
-            </a:pPr>
-            <a:r>
-              <a:rPr lang="en-US" sz="1000" b="1" dirty="0">
-                <a:solidFill>
-                  <a:srgbClr val="FFFFFF"/>
-                </a:solidFill>
-                <a:latin typeface="Malgun Gothic" pitchFamily="34" charset="0"/>
-                <a:ea typeface="Malgun Gothic" pitchFamily="34" charset="-122"/>
-                <a:cs typeface="Malgun Gothic" pitchFamily="34" charset="-120"/>
-              </a:rPr>
-              <a:t>3</a:t>
-            </a:r>
-            <a:endParaRPr lang="en-US" sz="1000" dirty="0"/>
-          </a:p>
-        </p:txBody>
-      </p:sp>
-      <p:sp>
-        <p:nvSpPr>
-          <p:cNvPr id="32" name="Text 30"/>
-          <p:cNvSpPr/>
-          <p:nvPr/>
-        </p:nvSpPr>
-        <p:spPr>
-          <a:xfrm>
-            <a:off x="1168400" y="3086100"/>
-            <a:ext cx="1651000" cy="457200"/>
-          </a:xfrm>
-          <a:prstGeom prst="rect">
-            <a:avLst/>
-          </a:prstGeom>
-          <a:noFill/>
-          <a:ln/>
-        </p:spPr>
-        <p:txBody>
-          <a:bodyPr wrap="square" lIns="0" tIns="0" rIns="0" bIns="0" rtlCol="0" anchor="ctr"/>
-          <a:lstStyle/>
-          <a:p>
-            <a:pPr algn="l" indent="0" marL="0">
-              <a:lnSpc>
-                <a:spcPct val="105000"/>
-              </a:lnSpc>
-              <a:buNone/>
-            </a:pPr>
-            <a:r>
-              <a:rPr lang="en-US" sz="1050" b="1" dirty="0">
-                <a:solidFill>
-                  <a:srgbClr val="17375E"/>
-                </a:solidFill>
-                <a:latin typeface="Malgun Gothic" pitchFamily="34" charset="0"/>
-                <a:ea typeface="Malgun Gothic" pitchFamily="34" charset="-122"/>
-                <a:cs typeface="Malgun Gothic" pitchFamily="34" charset="-120"/>
-              </a:rPr>
-              <a:t>저장</a:t>
-            </a:r>
-            <a:endParaRPr lang="en-US" sz="1050" dirty="0"/>
-          </a:p>
-        </p:txBody>
-      </p:sp>
-      <p:sp>
-        <p:nvSpPr>
-          <p:cNvPr id="33" name="Shape 31"/>
-          <p:cNvSpPr/>
-          <p:nvPr/>
-        </p:nvSpPr>
-        <p:spPr>
-          <a:xfrm>
-            <a:off x="2946400" y="3124200"/>
-            <a:ext cx="7823200" cy="381000"/>
-          </a:xfrm>
-          <a:prstGeom prst="rect">
-            <a:avLst/>
-          </a:prstGeom>
-          <a:solidFill>
-            <a:srgbClr val="DEE5EF"/>
-          </a:solidFill>
-          <a:ln w="15875">
-            <a:solidFill>
-              <a:srgbClr val="17375E"/>
-            </a:solidFill>
-            <a:prstDash val="solid"/>
-          </a:ln>
-        </p:spPr>
-      </p:sp>
-      <p:sp>
-        <p:nvSpPr>
-          <p:cNvPr id="34" name="Text 32"/>
-          <p:cNvSpPr/>
-          <p:nvPr/>
-        </p:nvSpPr>
-        <p:spPr>
-          <a:xfrm>
-            <a:off x="2997200" y="3149600"/>
-            <a:ext cx="7721600" cy="330200"/>
-          </a:xfrm>
-          <a:prstGeom prst="rect">
-            <a:avLst/>
-          </a:prstGeom>
-          <a:noFill/>
-          <a:ln/>
-        </p:spPr>
-        <p:txBody>
-          <a:bodyPr wrap="square" lIns="0" tIns="0" rIns="0" bIns="0" rtlCol="0" anchor="ctr"/>
-          <a:lstStyle/>
-          <a:p>
-            <a:pPr algn="ctr" indent="0" marL="0">
-              <a:lnSpc>
-                <a:spcPct val="105000"/>
-              </a:lnSpc>
-              <a:buNone/>
-            </a:pPr>
-            <a:r>
-              <a:rPr lang="en-US" sz="1050" b="1" dirty="0">
-                <a:solidFill>
-                  <a:srgbClr val="17375E"/>
-                </a:solidFill>
-                <a:latin typeface="Malgun Gothic" pitchFamily="34" charset="0"/>
-                <a:ea typeface="Malgun Gothic" pitchFamily="34" charset="-122"/>
-                <a:cs typeface="Malgun Gothic" pitchFamily="34" charset="-120"/>
-              </a:rPr>
-              <a:t>시계열 DB · 메트릭/이벤트 저장소</a:t>
-            </a:r>
-            <a:endParaRPr lang="en-US" sz="1050" dirty="0"/>
-          </a:p>
-        </p:txBody>
-      </p:sp>
-      <p:sp>
-        <p:nvSpPr>
-          <p:cNvPr id="35" name="Shape 33"/>
-          <p:cNvSpPr/>
-          <p:nvPr/>
-        </p:nvSpPr>
-        <p:spPr>
-          <a:xfrm>
-            <a:off x="762000" y="3708400"/>
-            <a:ext cx="10160000" cy="533400"/>
-          </a:xfrm>
-          <a:prstGeom prst="rect">
-            <a:avLst/>
-          </a:prstGeom>
-          <a:solidFill>
-            <a:srgbClr val="FFFFFF"/>
-          </a:solidFill>
-          <a:ln w="9525">
-            <a:solidFill>
-              <a:srgbClr val="C9D2DE"/>
-            </a:solidFill>
-            <a:prstDash val="solid"/>
-          </a:ln>
-        </p:spPr>
-      </p:sp>
-      <p:sp>
-        <p:nvSpPr>
-          <p:cNvPr id="36" name="Shape 34"/>
-          <p:cNvSpPr/>
-          <p:nvPr/>
-        </p:nvSpPr>
-        <p:spPr>
-          <a:xfrm>
-            <a:off x="863600" y="3860800"/>
-            <a:ext cx="228600" cy="228600"/>
-          </a:xfrm>
-          <a:prstGeom prst="ellipse">
-            <a:avLst/>
-          </a:prstGeom>
-          <a:solidFill>
-            <a:srgbClr val="17375E"/>
-          </a:solidFill>
-          <a:ln/>
-        </p:spPr>
-      </p:sp>
-      <p:sp>
-        <p:nvSpPr>
-          <p:cNvPr id="37" name="Text 35"/>
-          <p:cNvSpPr/>
-          <p:nvPr/>
-        </p:nvSpPr>
-        <p:spPr>
-          <a:xfrm>
-            <a:off x="863600" y="3860800"/>
-            <a:ext cx="228600" cy="228600"/>
-          </a:xfrm>
-          <a:prstGeom prst="rect">
-            <a:avLst/>
-          </a:prstGeom>
-          <a:noFill/>
-          <a:ln/>
-        </p:spPr>
-        <p:txBody>
-          <a:bodyPr wrap="square" lIns="0" tIns="0" rIns="0" bIns="0" rtlCol="0" anchor="ctr"/>
-          <a:lstStyle/>
-          <a:p>
-            <a:pPr algn="ctr" indent="0" marL="0">
-              <a:lnSpc>
-                <a:spcPct val="115000"/>
-              </a:lnSpc>
-              <a:buNone/>
-            </a:pPr>
-            <a:r>
-              <a:rPr lang="en-US" sz="1000" b="1" dirty="0">
-                <a:solidFill>
-                  <a:srgbClr val="FFFFFF"/>
-                </a:solidFill>
-                <a:latin typeface="Malgun Gothic" pitchFamily="34" charset="0"/>
-                <a:ea typeface="Malgun Gothic" pitchFamily="34" charset="-122"/>
-                <a:cs typeface="Malgun Gothic" pitchFamily="34" charset="-120"/>
-              </a:rPr>
-              <a:t>2</a:t>
-            </a:r>
-            <a:endParaRPr lang="en-US" sz="1000" dirty="0"/>
-          </a:p>
-        </p:txBody>
-      </p:sp>
-      <p:sp>
-        <p:nvSpPr>
-          <p:cNvPr id="38" name="Text 36"/>
-          <p:cNvSpPr/>
-          <p:nvPr/>
-        </p:nvSpPr>
-        <p:spPr>
-          <a:xfrm>
-            <a:off x="1168400" y="3746500"/>
-            <a:ext cx="1651000" cy="457200"/>
-          </a:xfrm>
-          <a:prstGeom prst="rect">
-            <a:avLst/>
-          </a:prstGeom>
-          <a:noFill/>
-          <a:ln/>
-        </p:spPr>
-        <p:txBody>
-          <a:bodyPr wrap="square" lIns="0" tIns="0" rIns="0" bIns="0" rtlCol="0" anchor="ctr"/>
-          <a:lstStyle/>
-          <a:p>
-            <a:pPr algn="l" indent="0" marL="0">
-              <a:lnSpc>
-                <a:spcPct val="105000"/>
-              </a:lnSpc>
-              <a:buNone/>
-            </a:pPr>
-            <a:r>
-              <a:rPr lang="en-US" sz="1050" b="1" dirty="0">
-                <a:solidFill>
-                  <a:srgbClr val="17375E"/>
-                </a:solidFill>
-                <a:latin typeface="Malgun Gothic" pitchFamily="34" charset="0"/>
-                <a:ea typeface="Malgun Gothic" pitchFamily="34" charset="-122"/>
-                <a:cs typeface="Malgun Gothic" pitchFamily="34" charset="-120"/>
-              </a:rPr>
-              <a:t>수집 파이프라인</a:t>
-            </a:r>
-            <a:endParaRPr lang="en-US" sz="1050" dirty="0"/>
-          </a:p>
-        </p:txBody>
-      </p:sp>
-      <p:sp>
-        <p:nvSpPr>
-          <p:cNvPr id="39" name="Shape 37"/>
-          <p:cNvSpPr/>
-          <p:nvPr/>
-        </p:nvSpPr>
-        <p:spPr>
-          <a:xfrm>
-            <a:off x="2946400" y="3784600"/>
-            <a:ext cx="7823200" cy="381000"/>
-          </a:xfrm>
-          <a:prstGeom prst="rect">
-            <a:avLst/>
-          </a:prstGeom>
-          <a:solidFill>
-            <a:srgbClr val="FCEBD2"/>
-          </a:solidFill>
-          <a:ln w="15875">
-            <a:solidFill>
-              <a:srgbClr val="D97E00"/>
-            </a:solidFill>
-            <a:prstDash val="solid"/>
-          </a:ln>
-        </p:spPr>
-      </p:sp>
-      <p:sp>
-        <p:nvSpPr>
-          <p:cNvPr id="40" name="Text 38"/>
-          <p:cNvSpPr/>
-          <p:nvPr/>
-        </p:nvSpPr>
-        <p:spPr>
-          <a:xfrm>
-            <a:off x="2997200" y="3810000"/>
-            <a:ext cx="7721600" cy="330200"/>
-          </a:xfrm>
-          <a:prstGeom prst="rect">
-            <a:avLst/>
-          </a:prstGeom>
-          <a:noFill/>
-          <a:ln/>
-        </p:spPr>
-        <p:txBody>
-          <a:bodyPr wrap="square" lIns="0" tIns="0" rIns="0" bIns="0" rtlCol="0" anchor="ctr"/>
-          <a:lstStyle/>
-          <a:p>
-            <a:pPr algn="ctr" indent="0" marL="0">
-              <a:lnSpc>
-                <a:spcPct val="105000"/>
-              </a:lnSpc>
-              <a:buNone/>
-            </a:pPr>
-            <a:r>
-              <a:rPr lang="en-US" sz="1050" b="1" dirty="0">
-                <a:solidFill>
-                  <a:srgbClr val="8A5000"/>
-                </a:solidFill>
-                <a:latin typeface="Malgun Gothic" pitchFamily="34" charset="0"/>
-                <a:ea typeface="Malgun Gothic" pitchFamily="34" charset="-122"/>
-                <a:cs typeface="Malgun Gothic" pitchFamily="34" charset="-120"/>
-              </a:rPr>
-              <a:t>OpenTelemetry Collector 기반 통합 파이프라인</a:t>
-            </a:r>
-            <a:endParaRPr lang="en-US" sz="1050" dirty="0"/>
-          </a:p>
-        </p:txBody>
-      </p:sp>
-      <p:sp>
-        <p:nvSpPr>
-          <p:cNvPr id="41" name="Shape 39"/>
-          <p:cNvSpPr/>
-          <p:nvPr/>
-        </p:nvSpPr>
-        <p:spPr>
-          <a:xfrm>
-            <a:off x="762000" y="4368800"/>
-            <a:ext cx="10160000" cy="787400"/>
-          </a:xfrm>
-          <a:prstGeom prst="rect">
-            <a:avLst/>
-          </a:prstGeom>
-          <a:solidFill>
-            <a:srgbClr val="FFFFFF"/>
-          </a:solidFill>
-          <a:ln w="9525">
-            <a:solidFill>
-              <a:srgbClr val="C9D2DE"/>
-            </a:solidFill>
-            <a:prstDash val="solid"/>
-          </a:ln>
-        </p:spPr>
-      </p:sp>
-      <p:sp>
-        <p:nvSpPr>
-          <p:cNvPr id="42" name="Shape 40"/>
-          <p:cNvSpPr/>
-          <p:nvPr/>
-        </p:nvSpPr>
-        <p:spPr>
-          <a:xfrm>
-            <a:off x="863600" y="4648200"/>
-            <a:ext cx="228600" cy="228600"/>
-          </a:xfrm>
-          <a:prstGeom prst="ellipse">
-            <a:avLst/>
-          </a:prstGeom>
-          <a:solidFill>
-            <a:srgbClr val="17375E"/>
-          </a:solidFill>
-          <a:ln/>
-        </p:spPr>
-      </p:sp>
-      <p:sp>
-        <p:nvSpPr>
-          <p:cNvPr id="43" name="Text 41"/>
-          <p:cNvSpPr/>
-          <p:nvPr/>
-        </p:nvSpPr>
-        <p:spPr>
-          <a:xfrm>
-            <a:off x="863600" y="4648200"/>
-            <a:ext cx="228600" cy="228600"/>
-          </a:xfrm>
-          <a:prstGeom prst="rect">
-            <a:avLst/>
-          </a:prstGeom>
-          <a:noFill/>
-          <a:ln/>
-        </p:spPr>
-        <p:txBody>
-          <a:bodyPr wrap="square" lIns="0" tIns="0" rIns="0" bIns="0" rtlCol="0" anchor="ctr"/>
-          <a:lstStyle/>
-          <a:p>
-            <a:pPr algn="ctr" indent="0" marL="0">
-              <a:lnSpc>
-                <a:spcPct val="115000"/>
-              </a:lnSpc>
-              <a:buNone/>
-            </a:pPr>
-            <a:r>
-              <a:rPr lang="en-US" sz="1000" b="1" dirty="0">
-                <a:solidFill>
-                  <a:srgbClr val="FFFFFF"/>
-                </a:solidFill>
-                <a:latin typeface="Malgun Gothic" pitchFamily="34" charset="0"/>
-                <a:ea typeface="Malgun Gothic" pitchFamily="34" charset="-122"/>
-                <a:cs typeface="Malgun Gothic" pitchFamily="34" charset="-120"/>
-              </a:rPr>
-              <a:t>1</a:t>
-            </a:r>
-            <a:endParaRPr lang="en-US" sz="1000" dirty="0"/>
-          </a:p>
-        </p:txBody>
-      </p:sp>
-      <p:sp>
-        <p:nvSpPr>
-          <p:cNvPr id="44" name="Text 42"/>
-          <p:cNvSpPr/>
-          <p:nvPr/>
-        </p:nvSpPr>
-        <p:spPr>
-          <a:xfrm>
-            <a:off x="1168400" y="4406900"/>
-            <a:ext cx="1651000" cy="711200"/>
-          </a:xfrm>
-          <a:prstGeom prst="rect">
-            <a:avLst/>
-          </a:prstGeom>
-          <a:noFill/>
-          <a:ln/>
-        </p:spPr>
-        <p:txBody>
-          <a:bodyPr wrap="square" lIns="0" tIns="0" rIns="0" bIns="0" rtlCol="0" anchor="ctr"/>
-          <a:lstStyle/>
-          <a:p>
-            <a:pPr algn="l" indent="0" marL="0">
-              <a:lnSpc>
-                <a:spcPct val="105000"/>
-              </a:lnSpc>
-              <a:buNone/>
-            </a:pPr>
-            <a:r>
-              <a:rPr lang="en-US" sz="1050" b="1" dirty="0">
-                <a:solidFill>
-                  <a:srgbClr val="17375E"/>
-                </a:solidFill>
-                <a:latin typeface="Malgun Gothic" pitchFamily="34" charset="0"/>
-                <a:ea typeface="Malgun Gothic" pitchFamily="34" charset="-122"/>
-                <a:cs typeface="Malgun Gothic" pitchFamily="34" charset="-120"/>
-              </a:rPr>
-              <a:t>수집 소스</a:t>
-            </a:r>
-            <a:endParaRPr lang="en-US" sz="1050" dirty="0"/>
-          </a:p>
-          <a:p>
-            <a:pPr algn="l" indent="0" marL="0">
-              <a:lnSpc>
-                <a:spcPct val="105000"/>
-              </a:lnSpc>
-              <a:buNone/>
-            </a:pPr>
-            <a:r>
-              <a:rPr lang="en-US" sz="1050" b="1" dirty="0">
-                <a:solidFill>
-                  <a:srgbClr val="17375E"/>
-                </a:solidFill>
-                <a:latin typeface="Malgun Gothic" pitchFamily="34" charset="0"/>
-                <a:ea typeface="Malgun Gothic" pitchFamily="34" charset="-122"/>
-                <a:cs typeface="Malgun Gothic" pitchFamily="34" charset="-120"/>
-              </a:rPr>
-              <a:t>(4개 도메인)</a:t>
-            </a:r>
-            <a:endParaRPr lang="en-US" sz="1050" dirty="0"/>
-          </a:p>
-        </p:txBody>
-      </p:sp>
-      <p:sp>
-        <p:nvSpPr>
-          <p:cNvPr id="45" name="Shape 43"/>
-          <p:cNvSpPr/>
-          <p:nvPr/>
-        </p:nvSpPr>
-        <p:spPr>
-          <a:xfrm>
-            <a:off x="2946400" y="4470400"/>
-            <a:ext cx="1498600" cy="584200"/>
+        </p:txBody>
+      </p:sp>
+      <p:sp>
+        <p:nvSpPr>
+          <p:cNvPr id="46" name="Shape 44"/>
+          <p:cNvSpPr/>
+          <p:nvPr/>
+        </p:nvSpPr>
+        <p:spPr>
+          <a:xfrm>
+            <a:off x="711200" y="5257800"/>
+            <a:ext cx="2540000" cy="355600"/>
           </a:xfrm>
           <a:prstGeom prst="rect">
             <a:avLst/>
@@ -23349,14 +23301,14 @@
       </p:sp>
       <p:sp>
         <p:nvSpPr>
-          <p:cNvPr id="46" name="Text 44"/>
-          <p:cNvSpPr/>
-          <p:nvPr/>
-        </p:nvSpPr>
-        <p:spPr>
-          <a:xfrm>
-            <a:off x="2997200" y="4495800"/>
-            <a:ext cx="1397000" cy="533400"/>
+          <p:cNvPr id="47" name="Text 45"/>
+          <p:cNvSpPr/>
+          <p:nvPr/>
+        </p:nvSpPr>
+        <p:spPr>
+          <a:xfrm>
+            <a:off x="762000" y="5283200"/>
+            <a:ext cx="2438400" cy="304800"/>
           </a:xfrm>
           <a:prstGeom prst="rect">
             <a:avLst/>
@@ -23375,7 +23327,7 @@
               <a:buNone/>
             </a:pPr>
             <a:r>
-              <a:rPr lang="en-US" sz="900" b="1" dirty="0">
+              <a:rPr lang="en-US" sz="850" b="1" dirty="0">
                 <a:solidFill>
                   <a:srgbClr val="3E6300"/>
                 </a:solidFill>
@@ -23383,52 +23335,32 @@
                 <a:ea typeface="Malgun Gothic" pitchFamily="34" charset="-122"/>
                 <a:cs typeface="Malgun Gothic" pitchFamily="34" charset="-120"/>
               </a:rPr>
-              <a:t>DCGM</a:t>
-            </a:r>
-            <a:endParaRPr lang="en-US" sz="900" dirty="0"/>
-          </a:p>
-          <a:p>
-            <a:pPr algn="ctr" indent="0" marL="0">
-              <a:lnSpc>
-                <a:spcPct val="105000"/>
-              </a:lnSpc>
-              <a:buNone/>
-            </a:pPr>
-            <a:r>
-              <a:rPr lang="en-US" sz="900" b="1" dirty="0">
-                <a:solidFill>
-                  <a:srgbClr val="3E6300"/>
-                </a:solidFill>
-                <a:latin typeface="Malgun Gothic" pitchFamily="34" charset="0"/>
-                <a:ea typeface="Malgun Gothic" pitchFamily="34" charset="-122"/>
-                <a:cs typeface="Malgun Gothic" pitchFamily="34" charset="-120"/>
-              </a:rPr>
-              <a:t>(GPU In-band)</a:t>
-            </a:r>
-            <a:endParaRPr lang="en-US" sz="900" dirty="0"/>
-          </a:p>
-        </p:txBody>
-      </p:sp>
-      <p:sp>
-        <p:nvSpPr>
-          <p:cNvPr id="47" name="Shape 45"/>
-          <p:cNvSpPr/>
-          <p:nvPr/>
-        </p:nvSpPr>
-        <p:spPr>
-          <a:xfrm>
-            <a:off x="4521200" y="4470400"/>
-            <a:ext cx="1574800" cy="584200"/>
+              <a:t>Health Automation · Resiliency</a:t>
+            </a:r>
+            <a:endParaRPr lang="en-US" sz="850" dirty="0"/>
+          </a:p>
+        </p:txBody>
+      </p:sp>
+      <p:sp>
+        <p:nvSpPr>
+          <p:cNvPr id="48" name="Shape 46"/>
+          <p:cNvSpPr/>
+          <p:nvPr/>
+        </p:nvSpPr>
+        <p:spPr>
+          <a:xfrm>
+            <a:off x="3454400" y="4572000"/>
+            <a:ext cx="2540000" cy="228600"/>
           </a:xfrm>
           <a:prstGeom prst="rect">
             <a:avLst/>
           </a:prstGeom>
           <a:solidFill>
-            <a:srgbClr val="DEE5EF"/>
+            <a:srgbClr val="FFFFFF"/>
           </a:solidFill>
-          <a:ln w="15875">
+          <a:ln w="9525">
             <a:solidFill>
-              <a:srgbClr val="17375E"/>
+              <a:srgbClr val="76B900"/>
             </a:solidFill>
             <a:prstDash val="solid"/>
           </a:ln>
@@ -23436,14 +23368,14 @@
       </p:sp>
       <p:sp>
         <p:nvSpPr>
-          <p:cNvPr id="48" name="Text 46"/>
-          <p:cNvSpPr/>
-          <p:nvPr/>
-        </p:nvSpPr>
-        <p:spPr>
-          <a:xfrm>
-            <a:off x="4572000" y="4495800"/>
-            <a:ext cx="1473200" cy="533400"/>
+          <p:cNvPr id="49" name="Text 47"/>
+          <p:cNvSpPr/>
+          <p:nvPr/>
+        </p:nvSpPr>
+        <p:spPr>
+          <a:xfrm>
+            <a:off x="3454400" y="4572000"/>
+            <a:ext cx="2540000" cy="228600"/>
           </a:xfrm>
           <a:prstGeom prst="rect">
             <a:avLst/>
@@ -23457,142 +23389,35 @@
           <a:p>
             <a:pPr algn="ctr" indent="0" marL="0">
               <a:lnSpc>
-                <a:spcPct val="105000"/>
+                <a:spcPct val="115000"/>
               </a:lnSpc>
               <a:buNone/>
             </a:pPr>
             <a:r>
-              <a:rPr lang="en-US" sz="900" b="1" dirty="0">
-                <a:solidFill>
-                  <a:srgbClr val="17375E"/>
-                </a:solidFill>
-                <a:latin typeface="Malgun Gothic" pitchFamily="34" charset="0"/>
-                <a:ea typeface="Malgun Gothic" pitchFamily="34" charset="-122"/>
-                <a:cs typeface="Malgun Gothic" pitchFamily="34" charset="-120"/>
-              </a:rPr>
-              <a:t>BMC + Redfish</a:t>
-            </a:r>
-            <a:endParaRPr lang="en-US" sz="900" dirty="0"/>
-          </a:p>
-          <a:p>
-            <a:pPr algn="ctr" indent="0" marL="0">
-              <a:lnSpc>
-                <a:spcPct val="105000"/>
-              </a:lnSpc>
-              <a:buNone/>
-            </a:pPr>
-            <a:r>
-              <a:rPr lang="en-US" sz="900" b="1" dirty="0">
-                <a:solidFill>
-                  <a:srgbClr val="17375E"/>
-                </a:solidFill>
-                <a:latin typeface="Malgun Gothic" pitchFamily="34" charset="0"/>
-                <a:ea typeface="Malgun Gothic" pitchFamily="34" charset="-122"/>
-                <a:cs typeface="Malgun Gothic" pitchFamily="34" charset="-120"/>
-              </a:rPr>
-              <a:t>수집기 (OOB)</a:t>
-            </a:r>
-            <a:endParaRPr lang="en-US" sz="900" dirty="0"/>
-          </a:p>
-        </p:txBody>
-      </p:sp>
-      <p:sp>
-        <p:nvSpPr>
-          <p:cNvPr id="49" name="Shape 47"/>
-          <p:cNvSpPr/>
-          <p:nvPr/>
-        </p:nvSpPr>
-        <p:spPr>
-          <a:xfrm>
-            <a:off x="6172200" y="4470400"/>
-            <a:ext cx="1549400" cy="584200"/>
-          </a:xfrm>
-          <a:prstGeom prst="rect">
-            <a:avLst/>
-          </a:prstGeom>
-          <a:solidFill>
-            <a:srgbClr val="FCEBD2"/>
-          </a:solidFill>
-          <a:ln w="15875">
-            <a:solidFill>
-              <a:srgbClr val="D97E00"/>
-            </a:solidFill>
-            <a:prstDash val="solid"/>
-          </a:ln>
-        </p:spPr>
-      </p:sp>
-      <p:sp>
-        <p:nvSpPr>
-          <p:cNvPr id="50" name="Text 48"/>
-          <p:cNvSpPr/>
-          <p:nvPr/>
-        </p:nvSpPr>
-        <p:spPr>
-          <a:xfrm>
-            <a:off x="6223000" y="4495800"/>
-            <a:ext cx="1447800" cy="533400"/>
-          </a:xfrm>
-          <a:prstGeom prst="rect">
-            <a:avLst/>
-          </a:prstGeom>
-          <a:noFill/>
-          <a:ln/>
-        </p:spPr>
-        <p:txBody>
-          <a:bodyPr wrap="square" lIns="0" tIns="0" rIns="0" bIns="0" rtlCol="0" anchor="ctr"/>
-          <a:lstStyle/>
-          <a:p>
-            <a:pPr algn="ctr" indent="0" marL="0">
-              <a:lnSpc>
-                <a:spcPct val="105000"/>
-              </a:lnSpc>
-              <a:buNone/>
-            </a:pPr>
-            <a:r>
-              <a:rPr lang="en-US" sz="850" b="1" dirty="0">
-                <a:solidFill>
-                  <a:srgbClr val="8A5000"/>
-                </a:solidFill>
-                <a:latin typeface="Malgun Gothic" pitchFamily="34" charset="0"/>
-                <a:ea typeface="Malgun Gothic" pitchFamily="34" charset="-122"/>
-                <a:cs typeface="Malgun Gothic" pitchFamily="34" charset="-120"/>
-              </a:rPr>
-              <a:t>BlueField DPU</a:t>
-            </a:r>
-            <a:endParaRPr lang="en-US" sz="850" dirty="0"/>
-          </a:p>
-          <a:p>
-            <a:pPr algn="ctr" indent="0" marL="0">
-              <a:lnSpc>
-                <a:spcPct val="105000"/>
-              </a:lnSpc>
-              <a:buNone/>
-            </a:pPr>
-            <a:r>
-              <a:rPr lang="en-US" sz="850" b="1" dirty="0">
-                <a:solidFill>
-                  <a:srgbClr val="8A5000"/>
-                </a:solidFill>
-                <a:latin typeface="Malgun Gothic" pitchFamily="34" charset="0"/>
-                <a:ea typeface="Malgun Gothic" pitchFamily="34" charset="-122"/>
-                <a:cs typeface="Malgun Gothic" pitchFamily="34" charset="-120"/>
-              </a:rPr>
-              <a:t>텔레메트리 오프로드</a:t>
-            </a:r>
-            <a:endParaRPr lang="en-US" sz="850" dirty="0"/>
-          </a:p>
-        </p:txBody>
-      </p:sp>
-      <p:sp>
-        <p:nvSpPr>
-          <p:cNvPr id="51" name="Shape 49"/>
-          <p:cNvSpPr/>
-          <p:nvPr/>
-        </p:nvSpPr>
-        <p:spPr>
-          <a:xfrm>
-            <a:off x="7797800" y="4470400"/>
-            <a:ext cx="1473200" cy="584200"/>
+              <a:rPr lang="en-US" sz="1000" b="1" dirty="0">
+                <a:solidFill>
+                  <a:srgbClr val="3E6300"/>
+                </a:solidFill>
+                <a:latin typeface="Malgun Gothic" pitchFamily="34" charset="0"/>
+                <a:ea typeface="Malgun Gothic" pitchFamily="34" charset="-122"/>
+                <a:cs typeface="Malgun Gothic" pitchFamily="34" charset="-120"/>
+              </a:rPr>
+              <a:t>Network</a:t>
+            </a:r>
+            <a:endParaRPr lang="en-US" sz="1000" dirty="0"/>
+          </a:p>
+        </p:txBody>
+      </p:sp>
+      <p:sp>
+        <p:nvSpPr>
+          <p:cNvPr id="50" name="Shape 48"/>
+          <p:cNvSpPr/>
+          <p:nvPr/>
+        </p:nvSpPr>
+        <p:spPr>
+          <a:xfrm>
+            <a:off x="3454400" y="4851400"/>
+            <a:ext cx="2540000" cy="355600"/>
           </a:xfrm>
           <a:prstGeom prst="rect">
             <a:avLst/>
@@ -23610,14 +23435,14 @@
       </p:sp>
       <p:sp>
         <p:nvSpPr>
-          <p:cNvPr id="52" name="Text 50"/>
-          <p:cNvSpPr/>
-          <p:nvPr/>
-        </p:nvSpPr>
-        <p:spPr>
-          <a:xfrm>
-            <a:off x="7848600" y="4495800"/>
-            <a:ext cx="1371600" cy="533400"/>
+          <p:cNvPr id="51" name="Text 49"/>
+          <p:cNvSpPr/>
+          <p:nvPr/>
+        </p:nvSpPr>
+        <p:spPr>
+          <a:xfrm>
+            <a:off x="3505200" y="4876800"/>
+            <a:ext cx="2438400" cy="304800"/>
           </a:xfrm>
           <a:prstGeom prst="rect">
             <a:avLst/>
@@ -23644,42 +23469,22 @@
                 <a:ea typeface="Malgun Gothic" pitchFamily="34" charset="-122"/>
                 <a:cs typeface="Malgun Gothic" pitchFamily="34" charset="-120"/>
               </a:rPr>
-              <a:t>UFM / Spectrum</a:t>
+              <a:t>UFM · Spectrum-6 패브릭 텔레메트리</a:t>
             </a:r>
             <a:endParaRPr lang="en-US" sz="850" dirty="0"/>
           </a:p>
-          <a:p>
-            <a:pPr algn="ctr" indent="0" marL="0">
-              <a:lnSpc>
-                <a:spcPct val="105000"/>
-              </a:lnSpc>
-              <a:buNone/>
-            </a:pPr>
-            <a:r>
-              <a:rPr lang="en-US" sz="850" b="1" dirty="0">
-                <a:solidFill>
-                  <a:srgbClr val="3E6300"/>
-                </a:solidFill>
-                <a:latin typeface="Malgun Gothic" pitchFamily="34" charset="0"/>
-                <a:ea typeface="Malgun Gothic" pitchFamily="34" charset="-122"/>
-                <a:cs typeface="Malgun Gothic" pitchFamily="34" charset="-120"/>
-              </a:rPr>
-              <a:t>패브릭 텔레메트리</a:t>
-            </a:r>
-            <a:endParaRPr lang="en-US" sz="850" dirty="0"/>
-          </a:p>
-        </p:txBody>
-      </p:sp>
-      <p:sp>
-        <p:nvSpPr>
-          <p:cNvPr id="53" name="Shape 51"/>
-          <p:cNvSpPr/>
-          <p:nvPr/>
-        </p:nvSpPr>
-        <p:spPr>
-          <a:xfrm>
-            <a:off x="9347200" y="4470400"/>
-            <a:ext cx="1422400" cy="584200"/>
+        </p:txBody>
+      </p:sp>
+      <p:sp>
+        <p:nvSpPr>
+          <p:cNvPr id="52" name="Shape 50"/>
+          <p:cNvSpPr/>
+          <p:nvPr/>
+        </p:nvSpPr>
+        <p:spPr>
+          <a:xfrm>
+            <a:off x="3454400" y="5257800"/>
+            <a:ext cx="2540000" cy="355600"/>
           </a:xfrm>
           <a:prstGeom prst="rect">
             <a:avLst/>
@@ -23697,14 +23502,14 @@
       </p:sp>
       <p:sp>
         <p:nvSpPr>
-          <p:cNvPr id="54" name="Text 52"/>
-          <p:cNvSpPr/>
-          <p:nvPr/>
-        </p:nvSpPr>
-        <p:spPr>
-          <a:xfrm>
-            <a:off x="9398000" y="4495800"/>
-            <a:ext cx="1320800" cy="533400"/>
+          <p:cNvPr id="53" name="Text 51"/>
+          <p:cNvSpPr/>
+          <p:nvPr/>
+        </p:nvSpPr>
+        <p:spPr>
+          <a:xfrm>
+            <a:off x="3505200" y="5283200"/>
+            <a:ext cx="2438400" cy="304800"/>
           </a:xfrm>
           <a:prstGeom prst="rect">
             <a:avLst/>
@@ -23731,10 +23536,124 @@
                 <a:ea typeface="Malgun Gothic" pitchFamily="34" charset="-122"/>
                 <a:cs typeface="Malgun Gothic" pitchFamily="34" charset="-120"/>
               </a:rPr>
-              <a:t>DSX Exchange</a:t>
+              <a:t>NMX Manager</a:t>
             </a:r>
             <a:endParaRPr lang="en-US" sz="850" dirty="0"/>
           </a:p>
+        </p:txBody>
+      </p:sp>
+      <p:sp>
+        <p:nvSpPr>
+          <p:cNvPr id="54" name="Shape 52"/>
+          <p:cNvSpPr/>
+          <p:nvPr/>
+        </p:nvSpPr>
+        <p:spPr>
+          <a:xfrm>
+            <a:off x="6197600" y="4572000"/>
+            <a:ext cx="2540000" cy="228600"/>
+          </a:xfrm>
+          <a:prstGeom prst="rect">
+            <a:avLst/>
+          </a:prstGeom>
+          <a:solidFill>
+            <a:srgbClr val="FFFFFF"/>
+          </a:solidFill>
+          <a:ln w="9525">
+            <a:solidFill>
+              <a:srgbClr val="76B900"/>
+            </a:solidFill>
+            <a:prstDash val="solid"/>
+          </a:ln>
+        </p:spPr>
+      </p:sp>
+      <p:sp>
+        <p:nvSpPr>
+          <p:cNvPr id="55" name="Text 53"/>
+          <p:cNvSpPr/>
+          <p:nvPr/>
+        </p:nvSpPr>
+        <p:spPr>
+          <a:xfrm>
+            <a:off x="6197600" y="4572000"/>
+            <a:ext cx="2540000" cy="228600"/>
+          </a:xfrm>
+          <a:prstGeom prst="rect">
+            <a:avLst/>
+          </a:prstGeom>
+          <a:noFill/>
+          <a:ln/>
+        </p:spPr>
+        <p:txBody>
+          <a:bodyPr wrap="square" lIns="0" tIns="0" rIns="0" bIns="0" rtlCol="0" anchor="ctr"/>
+          <a:lstStyle/>
+          <a:p>
+            <a:pPr algn="ctr" indent="0" marL="0">
+              <a:lnSpc>
+                <a:spcPct val="115000"/>
+              </a:lnSpc>
+              <a:buNone/>
+            </a:pPr>
+            <a:r>
+              <a:rPr lang="en-US" sz="1000" b="1" dirty="0">
+                <a:solidFill>
+                  <a:srgbClr val="3E6300"/>
+                </a:solidFill>
+                <a:latin typeface="Malgun Gothic" pitchFamily="34" charset="0"/>
+                <a:ea typeface="Malgun Gothic" pitchFamily="34" charset="-122"/>
+                <a:cs typeface="Malgun Gothic" pitchFamily="34" charset="-120"/>
+              </a:rPr>
+              <a:t>Storage</a:t>
+            </a:r>
+            <a:endParaRPr lang="en-US" sz="1000" dirty="0"/>
+          </a:p>
+        </p:txBody>
+      </p:sp>
+      <p:sp>
+        <p:nvSpPr>
+          <p:cNvPr id="56" name="Shape 54"/>
+          <p:cNvSpPr/>
+          <p:nvPr/>
+        </p:nvSpPr>
+        <p:spPr>
+          <a:xfrm>
+            <a:off x="6197600" y="4851400"/>
+            <a:ext cx="2540000" cy="355600"/>
+          </a:xfrm>
+          <a:prstGeom prst="rect">
+            <a:avLst/>
+          </a:prstGeom>
+          <a:solidFill>
+            <a:srgbClr val="E8F4D4"/>
+          </a:solidFill>
+          <a:ln w="15875">
+            <a:solidFill>
+              <a:srgbClr val="76B900"/>
+            </a:solidFill>
+            <a:prstDash val="solid"/>
+          </a:ln>
+        </p:spPr>
+      </p:sp>
+      <p:sp>
+        <p:nvSpPr>
+          <p:cNvPr id="57" name="Text 55"/>
+          <p:cNvSpPr/>
+          <p:nvPr/>
+        </p:nvSpPr>
+        <p:spPr>
+          <a:xfrm>
+            <a:off x="6248400" y="4876800"/>
+            <a:ext cx="2438400" cy="304800"/>
+          </a:xfrm>
+          <a:prstGeom prst="rect">
+            <a:avLst/>
+          </a:prstGeom>
+          <a:noFill/>
+          <a:ln/>
+        </p:spPr>
+        <p:txBody>
+          <a:bodyPr wrap="square" lIns="0" tIns="0" rIns="0" bIns="0" rtlCol="0" anchor="ctr"/>
+          <a:lstStyle/>
           <a:p>
             <a:pPr algn="ctr" indent="0" marL="0">
               <a:lnSpc>
@@ -23751,7 +23670,7 @@
                 <a:ea typeface="Malgun Gothic" pitchFamily="34" charset="-122"/>
                 <a:cs typeface="Malgun Gothic" pitchFamily="34" charset="-120"/>
               </a:rPr>
-              <a:t>(MQTT 전력·열)</a:t>
+              <a:t>BlueField-4 STX · NVMe-oF 텔레메트리</a:t>
             </a:r>
             <a:endParaRPr lang="en-US" sz="850" dirty="0"/>
           </a:p>
@@ -23759,328 +23678,338 @@
       </p:sp>
       <p:sp>
         <p:nvSpPr>
-          <p:cNvPr id="55" name="Shape 53"/>
-          <p:cNvSpPr/>
-          <p:nvPr/>
-        </p:nvSpPr>
-        <p:spPr>
-          <a:xfrm flipV="1">
-            <a:off x="3695700" y="4165600"/>
-            <a:ext cx="0" cy="304800"/>
-          </a:xfrm>
-          <a:prstGeom prst="line">
-            <a:avLst/>
-          </a:prstGeom>
-          <a:noFill/>
-          <a:ln w="19050">
+          <p:cNvPr id="58" name="Shape 56"/>
+          <p:cNvSpPr/>
+          <p:nvPr/>
+        </p:nvSpPr>
+        <p:spPr>
+          <a:xfrm>
+            <a:off x="6197600" y="5257800"/>
+            <a:ext cx="2540000" cy="355600"/>
+          </a:xfrm>
+          <a:prstGeom prst="rect">
+            <a:avLst/>
+          </a:prstGeom>
+          <a:solidFill>
+            <a:srgbClr val="E8F4D4"/>
+          </a:solidFill>
+          <a:ln w="15875">
             <a:solidFill>
-              <a:srgbClr val="9CA3AF"/>
+              <a:srgbClr val="76B900"/>
             </a:solidFill>
             <a:prstDash val="solid"/>
-            <a:headEnd type="none"/>
-            <a:tailEnd type="triangle"/>
           </a:ln>
         </p:spPr>
       </p:sp>
       <p:sp>
         <p:nvSpPr>
-          <p:cNvPr id="56" name="Shape 54"/>
-          <p:cNvSpPr/>
-          <p:nvPr/>
-        </p:nvSpPr>
-        <p:spPr>
-          <a:xfrm flipV="1">
-            <a:off x="5308600" y="4165600"/>
-            <a:ext cx="0" cy="304800"/>
-          </a:xfrm>
-          <a:prstGeom prst="line">
+          <p:cNvPr id="59" name="Text 57"/>
+          <p:cNvSpPr/>
+          <p:nvPr/>
+        </p:nvSpPr>
+        <p:spPr>
+          <a:xfrm>
+            <a:off x="6248400" y="5283200"/>
+            <a:ext cx="2438400" cy="304800"/>
+          </a:xfrm>
+          <a:prstGeom prst="rect">
             <a:avLst/>
           </a:prstGeom>
           <a:noFill/>
-          <a:ln w="19050">
+          <a:ln/>
+        </p:spPr>
+        <p:txBody>
+          <a:bodyPr wrap="square" lIns="0" tIns="0" rIns="0" bIns="0" rtlCol="0" anchor="ctr"/>
+          <a:lstStyle/>
+          <a:p>
+            <a:pPr algn="ctr" indent="0" marL="0">
+              <a:lnSpc>
+                <a:spcPct val="105000"/>
+              </a:lnSpc>
+              <a:buNone/>
+            </a:pPr>
+            <a:r>
+              <a:rPr lang="en-US" sz="850" b="1" dirty="0">
+                <a:solidFill>
+                  <a:srgbClr val="3E6300"/>
+                </a:solidFill>
+                <a:latin typeface="Malgun Gothic" pitchFamily="34" charset="0"/>
+                <a:ea typeface="Malgun Gothic" pitchFamily="34" charset="-122"/>
+                <a:cs typeface="Malgun Gothic" pitchFamily="34" charset="-120"/>
+              </a:rPr>
+              <a:t>DPU 텔레메트리 오프로드</a:t>
+            </a:r>
+            <a:endParaRPr lang="en-US" sz="850" dirty="0"/>
+          </a:p>
+        </p:txBody>
+      </p:sp>
+      <p:sp>
+        <p:nvSpPr>
+          <p:cNvPr id="60" name="Shape 58"/>
+          <p:cNvSpPr/>
+          <p:nvPr/>
+        </p:nvSpPr>
+        <p:spPr>
+          <a:xfrm>
+            <a:off x="8940800" y="4572000"/>
+            <a:ext cx="2540000" cy="228600"/>
+          </a:xfrm>
+          <a:prstGeom prst="rect">
+            <a:avLst/>
+          </a:prstGeom>
+          <a:solidFill>
+            <a:srgbClr val="FFFFFF"/>
+          </a:solidFill>
+          <a:ln w="9525">
             <a:solidFill>
-              <a:srgbClr val="9CA3AF"/>
+              <a:srgbClr val="76B900"/>
             </a:solidFill>
             <a:prstDash val="solid"/>
-            <a:headEnd type="none"/>
-            <a:tailEnd type="triangle"/>
           </a:ln>
         </p:spPr>
       </p:sp>
       <p:sp>
         <p:nvSpPr>
-          <p:cNvPr id="57" name="Shape 55"/>
-          <p:cNvSpPr/>
-          <p:nvPr/>
-        </p:nvSpPr>
-        <p:spPr>
-          <a:xfrm flipV="1">
-            <a:off x="6946900" y="4165600"/>
-            <a:ext cx="0" cy="304800"/>
-          </a:xfrm>
-          <a:prstGeom prst="line">
+          <p:cNvPr id="61" name="Text 59"/>
+          <p:cNvSpPr/>
+          <p:nvPr/>
+        </p:nvSpPr>
+        <p:spPr>
+          <a:xfrm>
+            <a:off x="8940800" y="4572000"/>
+            <a:ext cx="2540000" cy="228600"/>
+          </a:xfrm>
+          <a:prstGeom prst="rect">
             <a:avLst/>
           </a:prstGeom>
           <a:noFill/>
-          <a:ln w="19050">
+          <a:ln/>
+        </p:spPr>
+        <p:txBody>
+          <a:bodyPr wrap="square" lIns="0" tIns="0" rIns="0" bIns="0" rtlCol="0" anchor="ctr"/>
+          <a:lstStyle/>
+          <a:p>
+            <a:pPr algn="ctr" indent="0" marL="0">
+              <a:lnSpc>
+                <a:spcPct val="115000"/>
+              </a:lnSpc>
+              <a:buNone/>
+            </a:pPr>
+            <a:r>
+              <a:rPr lang="en-US" sz="1000" b="1" dirty="0">
+                <a:solidFill>
+                  <a:srgbClr val="3E6300"/>
+                </a:solidFill>
+                <a:latin typeface="Malgun Gothic" pitchFamily="34" charset="0"/>
+                <a:ea typeface="Malgun Gothic" pitchFamily="34" charset="-122"/>
+                <a:cs typeface="Malgun Gothic" pitchFamily="34" charset="-120"/>
+              </a:rPr>
+              <a:t>Facility</a:t>
+            </a:r>
+            <a:endParaRPr lang="en-US" sz="1000" dirty="0"/>
+          </a:p>
+        </p:txBody>
+      </p:sp>
+      <p:sp>
+        <p:nvSpPr>
+          <p:cNvPr id="62" name="Shape 60"/>
+          <p:cNvSpPr/>
+          <p:nvPr/>
+        </p:nvSpPr>
+        <p:spPr>
+          <a:xfrm>
+            <a:off x="8940800" y="4851400"/>
+            <a:ext cx="2540000" cy="355600"/>
+          </a:xfrm>
+          <a:prstGeom prst="rect">
+            <a:avLst/>
+          </a:prstGeom>
+          <a:solidFill>
+            <a:srgbClr val="E8F4D4"/>
+          </a:solidFill>
+          <a:ln w="15875">
             <a:solidFill>
-              <a:srgbClr val="9CA3AF"/>
+              <a:srgbClr val="76B900"/>
             </a:solidFill>
             <a:prstDash val="solid"/>
-            <a:headEnd type="none"/>
-            <a:tailEnd type="triangle"/>
           </a:ln>
         </p:spPr>
       </p:sp>
       <p:sp>
         <p:nvSpPr>
-          <p:cNvPr id="58" name="Shape 56"/>
-          <p:cNvSpPr/>
-          <p:nvPr/>
-        </p:nvSpPr>
-        <p:spPr>
-          <a:xfrm flipV="1">
-            <a:off x="8534400" y="4165600"/>
-            <a:ext cx="0" cy="304800"/>
-          </a:xfrm>
-          <a:prstGeom prst="line">
+          <p:cNvPr id="63" name="Text 61"/>
+          <p:cNvSpPr/>
+          <p:nvPr/>
+        </p:nvSpPr>
+        <p:spPr>
+          <a:xfrm>
+            <a:off x="8991600" y="4876800"/>
+            <a:ext cx="2438400" cy="304800"/>
+          </a:xfrm>
+          <a:prstGeom prst="rect">
             <a:avLst/>
           </a:prstGeom>
           <a:noFill/>
-          <a:ln w="19050">
+          <a:ln/>
+        </p:spPr>
+        <p:txBody>
+          <a:bodyPr wrap="square" lIns="0" tIns="0" rIns="0" bIns="0" rtlCol="0" anchor="ctr"/>
+          <a:lstStyle/>
+          <a:p>
+            <a:pPr algn="ctr" indent="0" marL="0">
+              <a:lnSpc>
+                <a:spcPct val="105000"/>
+              </a:lnSpc>
+              <a:buNone/>
+            </a:pPr>
+            <a:r>
+              <a:rPr lang="en-US" sz="850" b="1" dirty="0">
+                <a:solidFill>
+                  <a:srgbClr val="3E6300"/>
+                </a:solidFill>
+                <a:latin typeface="Malgun Gothic" pitchFamily="34" charset="0"/>
+                <a:ea typeface="Malgun Gothic" pitchFamily="34" charset="-122"/>
+                <a:cs typeface="Malgun Gothic" pitchFamily="34" charset="-120"/>
+              </a:rPr>
+              <a:t>DSX Exchange (MQTT IT/OT 허브)</a:t>
+            </a:r>
+            <a:endParaRPr lang="en-US" sz="850" dirty="0"/>
+          </a:p>
+        </p:txBody>
+      </p:sp>
+      <p:sp>
+        <p:nvSpPr>
+          <p:cNvPr id="64" name="Shape 62"/>
+          <p:cNvSpPr/>
+          <p:nvPr/>
+        </p:nvSpPr>
+        <p:spPr>
+          <a:xfrm>
+            <a:off x="8940800" y="5257800"/>
+            <a:ext cx="2540000" cy="355600"/>
+          </a:xfrm>
+          <a:prstGeom prst="rect">
+            <a:avLst/>
+          </a:prstGeom>
+          <a:solidFill>
+            <a:srgbClr val="E8F4D4"/>
+          </a:solidFill>
+          <a:ln w="15875">
             <a:solidFill>
-              <a:srgbClr val="9CA3AF"/>
+              <a:srgbClr val="76B900"/>
             </a:solidFill>
             <a:prstDash val="solid"/>
-            <a:headEnd type="none"/>
-            <a:tailEnd type="triangle"/>
           </a:ln>
         </p:spPr>
       </p:sp>
       <p:sp>
         <p:nvSpPr>
-          <p:cNvPr id="59" name="Shape 57"/>
-          <p:cNvSpPr/>
-          <p:nvPr/>
-        </p:nvSpPr>
-        <p:spPr>
-          <a:xfrm flipV="1">
-            <a:off x="10058400" y="4165600"/>
-            <a:ext cx="0" cy="304800"/>
-          </a:xfrm>
-          <a:prstGeom prst="line">
+          <p:cNvPr id="65" name="Text 63"/>
+          <p:cNvSpPr/>
+          <p:nvPr/>
+        </p:nvSpPr>
+        <p:spPr>
+          <a:xfrm>
+            <a:off x="8991600" y="5283200"/>
+            <a:ext cx="2438400" cy="304800"/>
+          </a:xfrm>
+          <a:prstGeom prst="rect">
             <a:avLst/>
           </a:prstGeom>
           <a:noFill/>
-          <a:ln w="19050">
+          <a:ln/>
+        </p:spPr>
+        <p:txBody>
+          <a:bodyPr wrap="square" lIns="0" tIns="0" rIns="0" bIns="0" rtlCol="0" anchor="ctr"/>
+          <a:lstStyle/>
+          <a:p>
+            <a:pPr algn="ctr" indent="0" marL="0">
+              <a:lnSpc>
+                <a:spcPct val="105000"/>
+              </a:lnSpc>
+              <a:buNone/>
+            </a:pPr>
+            <a:r>
+              <a:rPr lang="en-US" sz="850" b="1" dirty="0">
+                <a:solidFill>
+                  <a:srgbClr val="3E6300"/>
+                </a:solidFill>
+                <a:latin typeface="Malgun Gothic" pitchFamily="34" charset="0"/>
+                <a:ea typeface="Malgun Gothic" pitchFamily="34" charset="-122"/>
+                <a:cs typeface="Malgun Gothic" pitchFamily="34" charset="-120"/>
+              </a:rPr>
+              <a:t>전력·열·그리드 이벤트 노출</a:t>
+            </a:r>
+            <a:endParaRPr lang="en-US" sz="850" dirty="0"/>
+          </a:p>
+        </p:txBody>
+      </p:sp>
+      <p:sp>
+        <p:nvSpPr>
+          <p:cNvPr id="66" name="Shape 64"/>
+          <p:cNvSpPr/>
+          <p:nvPr/>
+        </p:nvSpPr>
+        <p:spPr>
+          <a:xfrm>
+            <a:off x="711200" y="5664200"/>
+            <a:ext cx="10769600" cy="228600"/>
+          </a:xfrm>
+          <a:prstGeom prst="rect">
+            <a:avLst/>
+          </a:prstGeom>
+          <a:solidFill>
+            <a:srgbClr val="E8F4D4"/>
+          </a:solidFill>
+          <a:ln w="9525">
             <a:solidFill>
-              <a:srgbClr val="9CA3AF"/>
+              <a:srgbClr val="76B900"/>
             </a:solidFill>
             <a:prstDash val="solid"/>
-            <a:headEnd type="none"/>
-            <a:tailEnd type="triangle"/>
           </a:ln>
         </p:spPr>
       </p:sp>
       <p:sp>
         <p:nvSpPr>
-          <p:cNvPr id="60" name="Shape 58"/>
-          <p:cNvSpPr/>
-          <p:nvPr/>
-        </p:nvSpPr>
-        <p:spPr>
-          <a:xfrm flipV="1">
-            <a:off x="6858000" y="3505200"/>
-            <a:ext cx="0" cy="279400"/>
-          </a:xfrm>
-          <a:prstGeom prst="line">
+          <p:cNvPr id="67" name="Text 65"/>
+          <p:cNvSpPr/>
+          <p:nvPr/>
+        </p:nvSpPr>
+        <p:spPr>
+          <a:xfrm>
+            <a:off x="711200" y="5664200"/>
+            <a:ext cx="10769600" cy="228600"/>
+          </a:xfrm>
+          <a:prstGeom prst="rect">
             <a:avLst/>
           </a:prstGeom>
           <a:noFill/>
-          <a:ln w="19050">
-            <a:solidFill>
-              <a:srgbClr val="9CA3AF"/>
-            </a:solidFill>
-            <a:prstDash val="solid"/>
-            <a:headEnd type="none"/>
-            <a:tailEnd type="triangle"/>
-          </a:ln>
-        </p:spPr>
-      </p:sp>
-      <p:sp>
-        <p:nvSpPr>
-          <p:cNvPr id="61" name="Shape 59"/>
-          <p:cNvSpPr/>
-          <p:nvPr/>
-        </p:nvSpPr>
-        <p:spPr>
-          <a:xfrm flipV="1">
-            <a:off x="3911600" y="2819400"/>
-            <a:ext cx="0" cy="304800"/>
-          </a:xfrm>
-          <a:prstGeom prst="line">
-            <a:avLst/>
-          </a:prstGeom>
-          <a:noFill/>
-          <a:ln w="19050">
-            <a:solidFill>
-              <a:srgbClr val="9CA3AF"/>
-            </a:solidFill>
-            <a:prstDash val="solid"/>
-            <a:headEnd type="none"/>
-            <a:tailEnd type="triangle"/>
-          </a:ln>
-        </p:spPr>
-      </p:sp>
-      <p:sp>
-        <p:nvSpPr>
-          <p:cNvPr id="62" name="Shape 60"/>
-          <p:cNvSpPr/>
-          <p:nvPr/>
-        </p:nvSpPr>
-        <p:spPr>
-          <a:xfrm flipV="1">
-            <a:off x="5918200" y="2819400"/>
-            <a:ext cx="0" cy="304800"/>
-          </a:xfrm>
-          <a:prstGeom prst="line">
-            <a:avLst/>
-          </a:prstGeom>
-          <a:noFill/>
-          <a:ln w="19050">
-            <a:solidFill>
-              <a:srgbClr val="9CA3AF"/>
-            </a:solidFill>
-            <a:prstDash val="solid"/>
-            <a:headEnd type="none"/>
-            <a:tailEnd type="triangle"/>
-          </a:ln>
-        </p:spPr>
-      </p:sp>
-      <p:sp>
-        <p:nvSpPr>
-          <p:cNvPr id="63" name="Shape 61"/>
-          <p:cNvSpPr/>
-          <p:nvPr/>
-        </p:nvSpPr>
-        <p:spPr>
-          <a:xfrm flipV="1">
-            <a:off x="7721600" y="2819400"/>
-            <a:ext cx="0" cy="304800"/>
-          </a:xfrm>
-          <a:prstGeom prst="line">
-            <a:avLst/>
-          </a:prstGeom>
-          <a:noFill/>
-          <a:ln w="19050">
-            <a:solidFill>
-              <a:srgbClr val="9CA3AF"/>
-            </a:solidFill>
-            <a:prstDash val="solid"/>
-            <a:headEnd type="none"/>
-            <a:tailEnd type="triangle"/>
-          </a:ln>
-        </p:spPr>
-      </p:sp>
-      <p:sp>
-        <p:nvSpPr>
-          <p:cNvPr id="64" name="Shape 62"/>
-          <p:cNvSpPr/>
-          <p:nvPr/>
-        </p:nvSpPr>
-        <p:spPr>
-          <a:xfrm flipV="1">
-            <a:off x="9664700" y="2819400"/>
-            <a:ext cx="0" cy="304800"/>
-          </a:xfrm>
-          <a:prstGeom prst="line">
-            <a:avLst/>
-          </a:prstGeom>
-          <a:noFill/>
-          <a:ln w="19050">
-            <a:solidFill>
-              <a:srgbClr val="9CA3AF"/>
-            </a:solidFill>
-            <a:prstDash val="solid"/>
-            <a:headEnd type="none"/>
-            <a:tailEnd type="triangle"/>
-          </a:ln>
-        </p:spPr>
-      </p:sp>
-      <p:sp>
-        <p:nvSpPr>
-          <p:cNvPr id="65" name="Shape 63"/>
-          <p:cNvSpPr/>
-          <p:nvPr/>
-        </p:nvSpPr>
-        <p:spPr>
-          <a:xfrm flipV="1">
-            <a:off x="3911600" y="2032000"/>
-            <a:ext cx="0" cy="330200"/>
-          </a:xfrm>
-          <a:prstGeom prst="line">
-            <a:avLst/>
-          </a:prstGeom>
-          <a:noFill/>
-          <a:ln w="19050">
-            <a:solidFill>
-              <a:srgbClr val="9CA3AF"/>
-            </a:solidFill>
-            <a:prstDash val="solid"/>
-            <a:headEnd type="none"/>
-            <a:tailEnd type="triangle"/>
-          </a:ln>
-        </p:spPr>
-      </p:sp>
-      <p:sp>
-        <p:nvSpPr>
-          <p:cNvPr id="66" name="Shape 64"/>
-          <p:cNvSpPr/>
-          <p:nvPr/>
-        </p:nvSpPr>
-        <p:spPr>
-          <a:xfrm flipV="1">
-            <a:off x="5918200" y="2032000"/>
-            <a:ext cx="0" cy="330200"/>
-          </a:xfrm>
-          <a:prstGeom prst="line">
-            <a:avLst/>
-          </a:prstGeom>
-          <a:noFill/>
-          <a:ln w="19050">
-            <a:solidFill>
-              <a:srgbClr val="9CA3AF"/>
-            </a:solidFill>
-            <a:prstDash val="solid"/>
-            <a:headEnd type="none"/>
-            <a:tailEnd type="triangle"/>
-          </a:ln>
-        </p:spPr>
-      </p:sp>
-      <p:sp>
-        <p:nvSpPr>
-          <p:cNvPr id="67" name="Shape 65"/>
-          <p:cNvSpPr/>
-          <p:nvPr/>
-        </p:nvSpPr>
-        <p:spPr>
-          <a:xfrm flipV="1">
-            <a:off x="7721600" y="2032000"/>
-            <a:ext cx="0" cy="330200"/>
-          </a:xfrm>
-          <a:prstGeom prst="line">
-            <a:avLst/>
-          </a:prstGeom>
-          <a:noFill/>
-          <a:ln w="19050">
-            <a:solidFill>
-              <a:srgbClr val="9CA3AF"/>
-            </a:solidFill>
-            <a:prstDash val="solid"/>
-            <a:headEnd type="none"/>
-            <a:tailEnd type="triangle"/>
-          </a:ln>
-        </p:spPr>
+          <a:ln/>
+        </p:spPr>
+        <p:txBody>
+          <a:bodyPr wrap="square" lIns="0" tIns="0" rIns="0" bIns="0" rtlCol="0" anchor="ctr"/>
+          <a:lstStyle/>
+          <a:p>
+            <a:pPr algn="ctr" indent="0" marL="0">
+              <a:lnSpc>
+                <a:spcPct val="115000"/>
+              </a:lnSpc>
+              <a:buNone/>
+            </a:pPr>
+            <a:r>
+              <a:rPr lang="en-US" sz="900" dirty="0">
+                <a:solidFill>
+                  <a:srgbClr val="3E6300"/>
+                </a:solidFill>
+                <a:latin typeface="Malgun Gothic" pitchFamily="34" charset="0"/>
+                <a:ea typeface="Malgun Gothic" pitchFamily="34" charset="-122"/>
+                <a:cs typeface="Malgun Gothic" pitchFamily="34" charset="-120"/>
+              </a:rPr>
+              <a:t>공통 기반: MCP 서버 카탈로그 · Lifecycle · Runtime Consistency · Multi-tenant · AI Platform Services (6개 모듈 — 상세: 백업 B, 15p)</a:t>
+            </a:r>
+            <a:endParaRPr lang="en-US" sz="900" dirty="0"/>
+          </a:p>
+        </p:txBody>
       </p:sp>
       <p:sp>
         <p:nvSpPr>
@@ -24089,75 +24018,8 @@
           <p:nvPr/>
         </p:nvSpPr>
         <p:spPr>
-          <a:xfrm flipH="1" flipV="1">
-            <a:off x="8940800" y="2032000"/>
-            <a:ext cx="723900" cy="330200"/>
-          </a:xfrm>
-          <a:prstGeom prst="line">
-            <a:avLst/>
-          </a:prstGeom>
-          <a:noFill/>
-          <a:ln w="19050">
-            <a:solidFill>
-              <a:srgbClr val="9CA3AF"/>
-            </a:solidFill>
-            <a:prstDash val="solid"/>
-            <a:headEnd type="none"/>
-            <a:tailEnd type="triangle"/>
-          </a:ln>
-        </p:spPr>
-      </p:sp>
-      <p:sp>
-        <p:nvSpPr>
-          <p:cNvPr id="69" name="Text 67"/>
-          <p:cNvSpPr/>
-          <p:nvPr/>
-        </p:nvSpPr>
-        <p:spPr>
-          <a:xfrm>
-            <a:off x="10947400" y="4368800"/>
-            <a:ext cx="736600" cy="838200"/>
-          </a:xfrm>
-          <a:prstGeom prst="rect">
-            <a:avLst/>
-          </a:prstGeom>
-          <a:noFill/>
-          <a:ln/>
-        </p:spPr>
-        <p:txBody>
-          <a:bodyPr wrap="square" lIns="0" tIns="0" rIns="0" bIns="0" rtlCol="0" anchor="t"/>
-          <a:lstStyle/>
-          <a:p>
-            <a:pPr algn="l" indent="0" marL="0">
-              <a:lnSpc>
-                <a:spcPct val="120000"/>
-              </a:lnSpc>
-              <a:buNone/>
-            </a:pPr>
-            <a:r>
-              <a:rPr lang="en-US" sz="800" dirty="0">
-                <a:solidFill>
-                  <a:srgbClr val="6B7280"/>
-                </a:solidFill>
-                <a:latin typeface="Malgun Gothic" pitchFamily="34" charset="0"/>
-                <a:ea typeface="Malgun Gothic" pitchFamily="34" charset="-122"/>
-                <a:cs typeface="Malgun Gothic" pitchFamily="34" charset="-120"/>
-              </a:rPr>
-              <a:t>Compute · Network · Storage · Facility</a:t>
-            </a:r>
-            <a:endParaRPr lang="en-US" sz="800" dirty="0"/>
-          </a:p>
-        </p:txBody>
-      </p:sp>
-      <p:sp>
-        <p:nvSpPr>
-          <p:cNvPr id="70" name="Shape 68"/>
-          <p:cNvSpPr/>
-          <p:nvPr/>
-        </p:nvSpPr>
-        <p:spPr>
-          <a:xfrm>
-            <a:off x="762000" y="5334000"/>
+          <a:xfrm>
+            <a:off x="508000" y="6045200"/>
             <a:ext cx="139700" cy="139700"/>
           </a:xfrm>
           <a:prstGeom prst="rect">
@@ -24176,14 +24038,14 @@
       </p:sp>
       <p:sp>
         <p:nvSpPr>
-          <p:cNvPr id="71" name="Text 69"/>
-          <p:cNvSpPr/>
-          <p:nvPr/>
-        </p:nvSpPr>
-        <p:spPr>
-          <a:xfrm>
-            <a:off x="952500" y="5308600"/>
-            <a:ext cx="1498600" cy="203200"/>
+          <p:cNvPr id="69" name="Text 67"/>
+          <p:cNvSpPr/>
+          <p:nvPr/>
+        </p:nvSpPr>
+        <p:spPr>
+          <a:xfrm>
+            <a:off x="698500" y="6019800"/>
+            <a:ext cx="1651000" cy="203200"/>
           </a:xfrm>
           <a:prstGeom prst="rect">
             <a:avLst/>
@@ -24218,13 +24080,13 @@
       </p:sp>
       <p:sp>
         <p:nvSpPr>
-          <p:cNvPr id="72" name="Shape 70"/>
-          <p:cNvSpPr/>
-          <p:nvPr/>
-        </p:nvSpPr>
-        <p:spPr>
-          <a:xfrm>
-            <a:off x="2540000" y="5334000"/>
+          <p:cNvPr id="70" name="Shape 68"/>
+          <p:cNvSpPr/>
+          <p:nvPr/>
+        </p:nvSpPr>
+        <p:spPr>
+          <a:xfrm>
+            <a:off x="2514600" y="6045200"/>
             <a:ext cx="139700" cy="139700"/>
           </a:xfrm>
           <a:prstGeom prst="rect">
@@ -24243,14 +24105,14 @@
       </p:sp>
       <p:sp>
         <p:nvSpPr>
-          <p:cNvPr id="73" name="Text 71"/>
-          <p:cNvSpPr/>
-          <p:nvPr/>
-        </p:nvSpPr>
-        <p:spPr>
-          <a:xfrm>
-            <a:off x="2730500" y="5308600"/>
-            <a:ext cx="1498600" cy="203200"/>
+          <p:cNvPr id="71" name="Text 69"/>
+          <p:cNvSpPr/>
+          <p:nvPr/>
+        </p:nvSpPr>
+        <p:spPr>
+          <a:xfrm>
+            <a:off x="2705100" y="6019800"/>
+            <a:ext cx="1143000" cy="203200"/>
           </a:xfrm>
           <a:prstGeom prst="rect">
             <a:avLst/>
@@ -24285,13 +24147,13 @@
       </p:sp>
       <p:sp>
         <p:nvSpPr>
-          <p:cNvPr id="74" name="Shape 72"/>
-          <p:cNvSpPr/>
-          <p:nvPr/>
-        </p:nvSpPr>
-        <p:spPr>
-          <a:xfrm>
-            <a:off x="4318000" y="5334000"/>
+          <p:cNvPr id="72" name="Shape 70"/>
+          <p:cNvSpPr/>
+          <p:nvPr/>
+        </p:nvSpPr>
+        <p:spPr>
+          <a:xfrm>
+            <a:off x="4013200" y="6045200"/>
             <a:ext cx="139700" cy="139700"/>
           </a:xfrm>
           <a:prstGeom prst="rect">
@@ -24310,14 +24172,14 @@
       </p:sp>
       <p:sp>
         <p:nvSpPr>
-          <p:cNvPr id="75" name="Text 73"/>
-          <p:cNvSpPr/>
-          <p:nvPr/>
-        </p:nvSpPr>
-        <p:spPr>
-          <a:xfrm>
-            <a:off x="4508500" y="5308600"/>
-            <a:ext cx="1498600" cy="203200"/>
+          <p:cNvPr id="73" name="Text 71"/>
+          <p:cNvSpPr/>
+          <p:nvPr/>
+        </p:nvSpPr>
+        <p:spPr>
+          <a:xfrm>
+            <a:off x="4203700" y="6019800"/>
+            <a:ext cx="2159000" cy="203200"/>
           </a:xfrm>
           <a:prstGeom prst="rect">
             <a:avLst/>
@@ -24344,7 +24206,7 @@
                 <a:ea typeface="Malgun Gothic" pitchFamily="34" charset="-122"/>
                 <a:cs typeface="Malgun Gothic" pitchFamily="34" charset="-120"/>
               </a:rPr>
-              <a:t>공동 개발</a:t>
+              <a:t>SKT 개발 (DSX OS 활용)</a:t>
             </a:r>
             <a:endParaRPr lang="en-US" sz="1050" dirty="0"/>
           </a:p>
@@ -24352,14 +24214,14 @@
       </p:sp>
       <p:sp>
         <p:nvSpPr>
-          <p:cNvPr id="76" name="Text 74"/>
-          <p:cNvSpPr/>
-          <p:nvPr/>
-        </p:nvSpPr>
-        <p:spPr>
-          <a:xfrm>
-            <a:off x="762000" y="5588000"/>
-            <a:ext cx="10160000" cy="355600"/>
+          <p:cNvPr id="74" name="Text 72"/>
+          <p:cNvSpPr/>
+          <p:nvPr/>
+        </p:nvSpPr>
+        <p:spPr>
+          <a:xfrm>
+            <a:off x="8128000" y="6019800"/>
+            <a:ext cx="3556000" cy="203200"/>
           </a:xfrm>
           <a:prstGeom prst="rect">
             <a:avLst/>
@@ -24371,7 +24233,7 @@
           <a:bodyPr wrap="square" lIns="0" tIns="0" rIns="0" bIns="0" rtlCol="0" anchor="t"/>
           <a:lstStyle/>
           <a:p>
-            <a:pPr algn="l" indent="0" marL="0">
+            <a:pPr algn="r" indent="0" marL="0">
               <a:lnSpc>
                 <a:spcPct val="115000"/>
               </a:lnSpc>
@@ -24386,7 +24248,7 @@
                 <a:ea typeface="Malgun Gothic" pitchFamily="34" charset="-122"/>
                 <a:cs typeface="Malgun Gothic" pitchFamily="34" charset="-120"/>
               </a:rPr>
-              <a:t>DSX OS: 2026-05 GTC Taipei 발표, 오픈소스·모듈러 — Lifecycle·Runtime Consistency·Health Automation·Resiliency·Multi-tenant·AI Platform Services 6개 모듈 (상세: 백업 B, 15p)</a:t>
+              <a:t>DSX OS: 2026-05 GTC Taipei 발표, 오픈소스·모듈러</a:t>
             </a:r>
             <a:endParaRPr lang="en-US" sz="950" dirty="0"/>
           </a:p>
@@ -24394,7 +24256,7 @@
       </p:sp>
       <p:sp>
         <p:nvSpPr>
-          <p:cNvPr id="77" name="Text 75"/>
+          <p:cNvPr id="75" name="Text 73"/>
           <p:cNvSpPr/>
           <p:nvPr/>
         </p:nvSpPr>
@@ -25251,7 +25113,7 @@
                           <a:ea typeface="Malgun Gothic" pitchFamily="34" charset="-122"/>
                           <a:cs typeface="Malgun Gothic" pitchFamily="34" charset="-120"/>
                         </a:rPr>
-                        <a:t>공동 · </a:t>
+                        <a:t>SKT+DSX · </a:t>
                       </a:r>
                       <a:pPr indent="0" marL="0">
                         <a:buNone/>
@@ -25265,7 +25127,7 @@
                           <a:ea typeface="Malgun Gothic" pitchFamily="34" charset="-122"/>
                           <a:cs typeface="Malgun Gothic" pitchFamily="34" charset="-120"/>
                         </a:rPr>
-                        <a:t>OTel 파이프라인 / SKT 시계열 DB</a:t>
+                        <a:t>OTel 파이프라인·시계열 DB (DSX 소스 연동)</a:t>
                       </a:r>
                       <a:endParaRPr lang="en-US" sz="1200" dirty="0"/>
                     </a:p>
@@ -25513,7 +25375,7 @@
                           <a:ea typeface="Malgun Gothic" pitchFamily="34" charset="-122"/>
                           <a:cs typeface="Malgun Gothic" pitchFamily="34" charset="-120"/>
                         </a:rPr>
-                        <a:t>Resiliency 모듈</a:t>
+                        <a:t>Resiliency 모듈 (정책은 SKT 정의)</a:t>
                       </a:r>
                       <a:pPr indent="0" marL="0">
                         <a:buNone/>
@@ -25803,7 +25665,7 @@
                           <a:ea typeface="Malgun Gothic" pitchFamily="34" charset="-122"/>
                           <a:cs typeface="Malgun Gothic" pitchFamily="34" charset="-120"/>
                         </a:rPr>
-                        <a:t>공동 · </a:t>
+                        <a:t>SKT+DSX · </a:t>
                       </a:r>
                       <a:pPr indent="0" marL="0">
                         <a:buNone/>
@@ -25817,7 +25679,7 @@
                           <a:ea typeface="Malgun Gothic" pitchFamily="34" charset="-122"/>
                           <a:cs typeface="Malgun Gothic" pitchFamily="34" charset="-120"/>
                         </a:rPr>
-                        <a:t>패브릭-잡 상관분석</a:t>
+                        <a:t>패브릭-잡 상관분석 — UFM 데이터 활용</a:t>
                       </a:r>
                       <a:endParaRPr lang="en-US" sz="1200" dirty="0"/>
                     </a:p>
@@ -26101,13 +25963,13 @@
                       <a:r>
                         <a:rPr lang="en-US" sz="950" b="1" dirty="0">
                           <a:solidFill>
-                            <a:srgbClr val="8A5000"/>
+                            <a:srgbClr val="3E6300"/>
                           </a:solidFill>
                           <a:latin typeface="Malgun Gothic" pitchFamily="34" charset="0"/>
                           <a:ea typeface="Malgun Gothic" pitchFamily="34" charset="-122"/>
                           <a:cs typeface="Malgun Gothic" pitchFamily="34" charset="-120"/>
                         </a:rPr>
-                        <a:t>공동 · </a:t>
+                        <a:t>DSX · </a:t>
                       </a:r>
                       <a:pPr indent="0" marL="0">
                         <a:buNone/>
@@ -26121,7 +25983,7 @@
                           <a:ea typeface="Malgun Gothic" pitchFamily="34" charset="-122"/>
                           <a:cs typeface="Malgun Gothic" pitchFamily="34" charset="-120"/>
                         </a:rPr>
-                        <a:t>BlueField STX·NVMe-oF 텔레메트리</a:t>
+                        <a:t>STX·NVMe-oF 텔레메트리 노출</a:t>
                       </a:r>
                       <a:endParaRPr lang="en-US" sz="1200" dirty="0"/>
                     </a:p>
@@ -26164,7 +26026,7 @@
                       <a:tailEnd type="none" w="med" len="med"/>
                     </a:lnB>
                     <a:solidFill>
-                      <a:srgbClr val="FCEBD2"/>
+                      <a:srgbClr val="E8F4D4"/>
                     </a:solidFill>
                   </a:tcPr>
                 </a:tc>
@@ -26709,7 +26571,7 @@
                           <a:ea typeface="Malgun Gothic" pitchFamily="34" charset="-122"/>
                           <a:cs typeface="Malgun Gothic" pitchFamily="34" charset="-120"/>
                         </a:rPr>
-                        <a:t>공동 · </a:t>
+                        <a:t>SKT+DSX · </a:t>
                       </a:r>
                       <a:pPr indent="0" marL="0">
                         <a:buNone/>
@@ -26723,7 +26585,7 @@
                           <a:ea typeface="Malgun Gothic" pitchFamily="34" charset="-122"/>
                           <a:cs typeface="Malgun Gothic" pitchFamily="34" charset="-120"/>
                         </a:rPr>
-                        <a:t>Facility-aware 상관 (SKT 경험 접목)</a:t>
+                        <a:t>Facility-aware 상관 — Exchange 데이터 활용 (SKT 경험)</a:t>
                       </a:r>
                       <a:endParaRPr lang="en-US" sz="1200" dirty="0"/>
                     </a:p>
@@ -26865,7 +26727,7 @@
                           <a:ea typeface="Malgun Gothic" pitchFamily="34" charset="-122"/>
                           <a:cs typeface="Malgun Gothic" pitchFamily="34" charset="-120"/>
                         </a:rPr>
-                        <a:t>공동 · </a:t>
+                        <a:t>SKT+DSX · </a:t>
                       </a:r>
                       <a:pPr indent="0" marL="0">
                         <a:buNone/>
@@ -26879,7 +26741,7 @@
                           <a:ea typeface="Malgun Gothic" pitchFamily="34" charset="-122"/>
                           <a:cs typeface="Malgun Gothic" pitchFamily="34" charset="-120"/>
                         </a:rPr>
-                        <a:t>공동 운영 절차</a:t>
+                        <a:t>SKT 운영 절차 주관 — Resiliency 연계</a:t>
                       </a:r>
                       <a:pPr indent="0" marL="0">
                         <a:buNone/>
@@ -27571,7 +27433,7 @@
                 <a:ea typeface="Malgun Gothic" pitchFamily="34" charset="-122"/>
                 <a:cs typeface="Malgun Gothic" pitchFamily="34" charset="-120"/>
               </a:rPr>
-              <a:t>주체 지정 20셀 중 SKT 단독 9 · DSX 6 · 공동 5(분할 포함) · 논의 필요 ★4</a:t>
+              <a:t>주체 지정 20셀 중 SKT 개발 13 (자체 9 + DSX 활용 4) · DSX OS 기본 제공 7 · 논의 필요 ★4</a:t>
             </a:r>
             <a:pPr indent="0" marL="0">
               <a:buNone/>
@@ -27585,7 +27447,7 @@
                 <a:ea typeface="Malgun Gothic" pitchFamily="34" charset="-122"/>
                 <a:cs typeface="Malgun Gothic" pitchFamily="34" charset="-120"/>
               </a:rPr>
-              <a:t> → 개발 총량의 절반 이상(11/20)을 DSX OS·공동 영역이 흡수</a:t>
+              <a:t> → 개발 주체는 SKT — 기반 7개 영역은 DSX OS가 제공해 개발 부담 경감</a:t>
             </a:r>
             <a:endParaRPr lang="en-US" sz="1000" dirty="0"/>
           </a:p>
@@ -27625,7 +27487,7 @@
         <p:spPr>
           <a:xfrm>
             <a:off x="698500" y="6045200"/>
-            <a:ext cx="1498600" cy="203200"/>
+            <a:ext cx="1651000" cy="203200"/>
           </a:xfrm>
           <a:prstGeom prst="rect">
             <a:avLst/>
@@ -27666,7 +27528,7 @@
         </p:nvSpPr>
         <p:spPr>
           <a:xfrm>
-            <a:off x="2286000" y="6070600"/>
+            <a:off x="2514600" y="6070600"/>
             <a:ext cx="139700" cy="139700"/>
           </a:xfrm>
           <a:prstGeom prst="rect">
@@ -27691,8 +27553,8 @@
         </p:nvSpPr>
         <p:spPr>
           <a:xfrm>
-            <a:off x="2476500" y="6045200"/>
-            <a:ext cx="1498600" cy="203200"/>
+            <a:off x="2705100" y="6045200"/>
+            <a:ext cx="1143000" cy="203200"/>
           </a:xfrm>
           <a:prstGeom prst="rect">
             <a:avLst/>
@@ -27733,7 +27595,7 @@
         </p:nvSpPr>
         <p:spPr>
           <a:xfrm>
-            <a:off x="4064000" y="6070600"/>
+            <a:off x="4013200" y="6070600"/>
             <a:ext cx="139700" cy="139700"/>
           </a:xfrm>
           <a:prstGeom prst="rect">
@@ -27758,8 +27620,8 @@
         </p:nvSpPr>
         <p:spPr>
           <a:xfrm>
-            <a:off x="4254500" y="6045200"/>
-            <a:ext cx="1498600" cy="203200"/>
+            <a:off x="4203700" y="6045200"/>
+            <a:ext cx="2159000" cy="203200"/>
           </a:xfrm>
           <a:prstGeom prst="rect">
             <a:avLst/>
@@ -27786,7 +27648,7 @@
                 <a:ea typeface="Malgun Gothic" pitchFamily="34" charset="-122"/>
                 <a:cs typeface="Malgun Gothic" pitchFamily="34" charset="-120"/>
               </a:rPr>
-              <a:t>공동 개발</a:t>
+              <a:t>SKT 개발 (DSX OS 활용)</a:t>
             </a:r>
             <a:endParaRPr lang="en-US" sz="1050" dirty="0"/>
           </a:p>
@@ -27828,7 +27690,7 @@
                 <a:ea typeface="Malgun Gothic" pitchFamily="34" charset="-122"/>
                 <a:cs typeface="Malgun Gothic" pitchFamily="34" charset="-120"/>
               </a:rPr>
-              <a:t>총 25셀 = 주체 지정 20 + 공용 4 + 해당 없음 1 (★는 오버레이)</a:t>
+              <a:t>총 25셀 = 주체 지정 20 + 공용 4 + 해당 없음 1 (★는 오버레이) · SKT+DSX = DSX OS 활용해 SKT가 개발</a:t>
             </a:r>
             <a:endParaRPr lang="en-US" sz="900" dirty="0"/>
           </a:p>
@@ -30336,7 +30198,7 @@
                 <a:ea typeface="Malgun Gothic" pitchFamily="34" charset="-122"/>
                 <a:cs typeface="Malgun Gothic" pitchFamily="34" charset="-120"/>
               </a:rPr>
-              <a:t> 공동 </a:t>
+              <a:t> SKT+DSX </a:t>
             </a:r>
             <a:pPr indent="0" marL="0">
               <a:buNone/>
@@ -30350,7 +30212,7 @@
                 <a:ea typeface="Malgun Gothic" pitchFamily="34" charset="-122"/>
                 <a:cs typeface="Malgun Gothic" pitchFamily="34" charset="-120"/>
               </a:rPr>
-              <a:t> 잡 메타 연계 커넥터    </a:t>
+              <a:t> 잡 메타 연계 커넥터 (스케줄러 연동)    </a:t>
             </a:r>
             <a:pPr indent="0" marL="0">
               <a:buNone/>

</xml_diff>